<commit_message>
Aggiunte documentazioni: doc + pres
</commit_message>
<xml_diff>
--- a/Documentazione/Presentazione_Rutolo_Santangelo.pptx
+++ b/Documentazione/Presentazione_Rutolo_Santangelo.pptx
@@ -5,16 +5,21 @@
     <p:sldMasterId id="2147484139" r:id="rId1"/>
   </p:sldMasterIdLst>
   <p:notesMasterIdLst>
-    <p:notesMasterId r:id="rId6"/>
+    <p:notesMasterId r:id="rId11"/>
   </p:notesMasterIdLst>
   <p:handoutMasterIdLst>
-    <p:handoutMasterId r:id="rId7"/>
+    <p:handoutMasterId r:id="rId12"/>
   </p:handoutMasterIdLst>
   <p:sldIdLst>
     <p:sldId id="268" r:id="rId2"/>
     <p:sldId id="266" r:id="rId3"/>
-    <p:sldId id="267" r:id="rId4"/>
-    <p:sldId id="263" r:id="rId5"/>
+    <p:sldId id="269" r:id="rId4"/>
+    <p:sldId id="273" r:id="rId5"/>
+    <p:sldId id="270" r:id="rId6"/>
+    <p:sldId id="271" r:id="rId7"/>
+    <p:sldId id="272" r:id="rId8"/>
+    <p:sldId id="275" r:id="rId9"/>
+    <p:sldId id="274" r:id="rId10"/>
   </p:sldIdLst>
   <p:sldSz cx="9144000" cy="5143500" type="screen16x9"/>
   <p:notesSz cx="6858000" cy="9144000"/>
@@ -162,6 +167,3352 @@
 </p:presentation>
 </file>
 
+<file path=ppt/diagrams/colors1.xml><?xml version="1.0" encoding="utf-8"?>
+<dgm:colorsDef xmlns:dgm="http://schemas.openxmlformats.org/drawingml/2006/diagram" xmlns:a="http://schemas.openxmlformats.org/drawingml/2006/main" uniqueId="urn:microsoft.com/office/officeart/2005/8/colors/accent1_2">
+  <dgm:title val=""/>
+  <dgm:desc val=""/>
+  <dgm:catLst>
+    <dgm:cat type="accent1" pri="11200"/>
+  </dgm:catLst>
+  <dgm:styleLbl name="node0">
+    <dgm:fillClrLst meth="repeat">
+      <a:schemeClr val="accent1"/>
+    </dgm:fillClrLst>
+    <dgm:linClrLst meth="repeat">
+      <a:schemeClr val="lt1"/>
+    </dgm:linClrLst>
+    <dgm:effectClrLst/>
+    <dgm:txLinClrLst/>
+    <dgm:txFillClrLst/>
+    <dgm:txEffectClrLst/>
+  </dgm:styleLbl>
+  <dgm:styleLbl name="alignNode1">
+    <dgm:fillClrLst meth="repeat">
+      <a:schemeClr val="accent1"/>
+    </dgm:fillClrLst>
+    <dgm:linClrLst meth="repeat">
+      <a:schemeClr val="accent1"/>
+    </dgm:linClrLst>
+    <dgm:effectClrLst/>
+    <dgm:txLinClrLst/>
+    <dgm:txFillClrLst/>
+    <dgm:txEffectClrLst/>
+  </dgm:styleLbl>
+  <dgm:styleLbl name="node1">
+    <dgm:fillClrLst meth="repeat">
+      <a:schemeClr val="accent1"/>
+    </dgm:fillClrLst>
+    <dgm:linClrLst meth="repeat">
+      <a:schemeClr val="lt1"/>
+    </dgm:linClrLst>
+    <dgm:effectClrLst/>
+    <dgm:txLinClrLst/>
+    <dgm:txFillClrLst/>
+    <dgm:txEffectClrLst/>
+  </dgm:styleLbl>
+  <dgm:styleLbl name="lnNode1">
+    <dgm:fillClrLst meth="repeat">
+      <a:schemeClr val="accent1"/>
+    </dgm:fillClrLst>
+    <dgm:linClrLst meth="repeat">
+      <a:schemeClr val="lt1"/>
+    </dgm:linClrLst>
+    <dgm:effectClrLst/>
+    <dgm:txLinClrLst/>
+    <dgm:txFillClrLst/>
+    <dgm:txEffectClrLst/>
+  </dgm:styleLbl>
+  <dgm:styleLbl name="vennNode1">
+    <dgm:fillClrLst meth="repeat">
+      <a:schemeClr val="accent1">
+        <a:alpha val="50000"/>
+      </a:schemeClr>
+    </dgm:fillClrLst>
+    <dgm:linClrLst meth="repeat">
+      <a:schemeClr val="lt1"/>
+    </dgm:linClrLst>
+    <dgm:effectClrLst/>
+    <dgm:txLinClrLst/>
+    <dgm:txFillClrLst/>
+    <dgm:txEffectClrLst/>
+  </dgm:styleLbl>
+  <dgm:styleLbl name="node2">
+    <dgm:fillClrLst meth="repeat">
+      <a:schemeClr val="accent1"/>
+    </dgm:fillClrLst>
+    <dgm:linClrLst meth="repeat">
+      <a:schemeClr val="lt1"/>
+    </dgm:linClrLst>
+    <dgm:effectClrLst/>
+    <dgm:txLinClrLst/>
+    <dgm:txFillClrLst/>
+    <dgm:txEffectClrLst/>
+  </dgm:styleLbl>
+  <dgm:styleLbl name="node3">
+    <dgm:fillClrLst meth="repeat">
+      <a:schemeClr val="accent1"/>
+    </dgm:fillClrLst>
+    <dgm:linClrLst meth="repeat">
+      <a:schemeClr val="lt1"/>
+    </dgm:linClrLst>
+    <dgm:effectClrLst/>
+    <dgm:txLinClrLst/>
+    <dgm:txFillClrLst/>
+    <dgm:txEffectClrLst/>
+  </dgm:styleLbl>
+  <dgm:styleLbl name="node4">
+    <dgm:fillClrLst meth="repeat">
+      <a:schemeClr val="accent1"/>
+    </dgm:fillClrLst>
+    <dgm:linClrLst meth="repeat">
+      <a:schemeClr val="lt1"/>
+    </dgm:linClrLst>
+    <dgm:effectClrLst/>
+    <dgm:txLinClrLst/>
+    <dgm:txFillClrLst/>
+    <dgm:txEffectClrLst/>
+  </dgm:styleLbl>
+  <dgm:styleLbl name="fgImgPlace1">
+    <dgm:fillClrLst meth="repeat">
+      <a:schemeClr val="accent1">
+        <a:tint val="50000"/>
+      </a:schemeClr>
+    </dgm:fillClrLst>
+    <dgm:linClrLst meth="repeat">
+      <a:schemeClr val="lt1"/>
+    </dgm:linClrLst>
+    <dgm:effectClrLst/>
+    <dgm:txLinClrLst/>
+    <dgm:txFillClrLst meth="repeat">
+      <a:schemeClr val="lt1"/>
+    </dgm:txFillClrLst>
+    <dgm:txEffectClrLst/>
+  </dgm:styleLbl>
+  <dgm:styleLbl name="alignImgPlace1">
+    <dgm:fillClrLst meth="repeat">
+      <a:schemeClr val="accent1">
+        <a:tint val="50000"/>
+      </a:schemeClr>
+    </dgm:fillClrLst>
+    <dgm:linClrLst meth="repeat">
+      <a:schemeClr val="lt1"/>
+    </dgm:linClrLst>
+    <dgm:effectClrLst/>
+    <dgm:txLinClrLst/>
+    <dgm:txFillClrLst meth="repeat">
+      <a:schemeClr val="lt1"/>
+    </dgm:txFillClrLst>
+    <dgm:txEffectClrLst/>
+  </dgm:styleLbl>
+  <dgm:styleLbl name="bgImgPlace1">
+    <dgm:fillClrLst meth="repeat">
+      <a:schemeClr val="accent1">
+        <a:tint val="50000"/>
+      </a:schemeClr>
+    </dgm:fillClrLst>
+    <dgm:linClrLst meth="repeat">
+      <a:schemeClr val="lt1"/>
+    </dgm:linClrLst>
+    <dgm:effectClrLst/>
+    <dgm:txLinClrLst/>
+    <dgm:txFillClrLst meth="repeat">
+      <a:schemeClr val="lt1"/>
+    </dgm:txFillClrLst>
+    <dgm:txEffectClrLst/>
+  </dgm:styleLbl>
+  <dgm:styleLbl name="sibTrans2D1">
+    <dgm:fillClrLst meth="repeat">
+      <a:schemeClr val="accent1">
+        <a:tint val="60000"/>
+      </a:schemeClr>
+    </dgm:fillClrLst>
+    <dgm:linClrLst meth="repeat">
+      <a:schemeClr val="accent1">
+        <a:tint val="60000"/>
+      </a:schemeClr>
+    </dgm:linClrLst>
+    <dgm:effectClrLst/>
+    <dgm:txLinClrLst/>
+    <dgm:txFillClrLst/>
+    <dgm:txEffectClrLst/>
+  </dgm:styleLbl>
+  <dgm:styleLbl name="fgSibTrans2D1">
+    <dgm:fillClrLst meth="repeat">
+      <a:schemeClr val="accent1">
+        <a:tint val="60000"/>
+      </a:schemeClr>
+    </dgm:fillClrLst>
+    <dgm:linClrLst meth="repeat">
+      <a:schemeClr val="accent1">
+        <a:tint val="60000"/>
+      </a:schemeClr>
+    </dgm:linClrLst>
+    <dgm:effectClrLst/>
+    <dgm:txLinClrLst/>
+    <dgm:txFillClrLst/>
+    <dgm:txEffectClrLst/>
+  </dgm:styleLbl>
+  <dgm:styleLbl name="bgSibTrans2D1">
+    <dgm:fillClrLst meth="repeat">
+      <a:schemeClr val="accent1">
+        <a:tint val="60000"/>
+      </a:schemeClr>
+    </dgm:fillClrLst>
+    <dgm:linClrLst meth="repeat">
+      <a:schemeClr val="accent1">
+        <a:tint val="60000"/>
+      </a:schemeClr>
+    </dgm:linClrLst>
+    <dgm:effectClrLst/>
+    <dgm:txLinClrLst/>
+    <dgm:txFillClrLst/>
+    <dgm:txEffectClrLst/>
+  </dgm:styleLbl>
+  <dgm:styleLbl name="sibTrans1D1">
+    <dgm:fillClrLst meth="repeat">
+      <a:schemeClr val="accent1"/>
+    </dgm:fillClrLst>
+    <dgm:linClrLst meth="repeat">
+      <a:schemeClr val="accent1"/>
+    </dgm:linClrLst>
+    <dgm:effectClrLst/>
+    <dgm:txLinClrLst/>
+    <dgm:txFillClrLst meth="repeat">
+      <a:schemeClr val="tx1"/>
+    </dgm:txFillClrLst>
+    <dgm:txEffectClrLst/>
+  </dgm:styleLbl>
+  <dgm:styleLbl name="callout">
+    <dgm:fillClrLst meth="repeat">
+      <a:schemeClr val="accent1"/>
+    </dgm:fillClrLst>
+    <dgm:linClrLst meth="repeat">
+      <a:schemeClr val="accent1">
+        <a:tint val="50000"/>
+      </a:schemeClr>
+    </dgm:linClrLst>
+    <dgm:effectClrLst/>
+    <dgm:txLinClrLst/>
+    <dgm:txFillClrLst meth="repeat">
+      <a:schemeClr val="tx1"/>
+    </dgm:txFillClrLst>
+    <dgm:txEffectClrLst/>
+  </dgm:styleLbl>
+  <dgm:styleLbl name="asst0">
+    <dgm:fillClrLst meth="repeat">
+      <a:schemeClr val="accent1"/>
+    </dgm:fillClrLst>
+    <dgm:linClrLst meth="repeat">
+      <a:schemeClr val="lt1"/>
+    </dgm:linClrLst>
+    <dgm:effectClrLst/>
+    <dgm:txLinClrLst/>
+    <dgm:txFillClrLst/>
+    <dgm:txEffectClrLst/>
+  </dgm:styleLbl>
+  <dgm:styleLbl name="asst1">
+    <dgm:fillClrLst meth="repeat">
+      <a:schemeClr val="accent1"/>
+    </dgm:fillClrLst>
+    <dgm:linClrLst meth="repeat">
+      <a:schemeClr val="lt1"/>
+    </dgm:linClrLst>
+    <dgm:effectClrLst/>
+    <dgm:txLinClrLst/>
+    <dgm:txFillClrLst/>
+    <dgm:txEffectClrLst/>
+  </dgm:styleLbl>
+  <dgm:styleLbl name="asst2">
+    <dgm:fillClrLst meth="repeat">
+      <a:schemeClr val="accent1"/>
+    </dgm:fillClrLst>
+    <dgm:linClrLst meth="repeat">
+      <a:schemeClr val="lt1"/>
+    </dgm:linClrLst>
+    <dgm:effectClrLst/>
+    <dgm:txLinClrLst/>
+    <dgm:txFillClrLst/>
+    <dgm:txEffectClrLst/>
+  </dgm:styleLbl>
+  <dgm:styleLbl name="asst3">
+    <dgm:fillClrLst meth="repeat">
+      <a:schemeClr val="accent1"/>
+    </dgm:fillClrLst>
+    <dgm:linClrLst meth="repeat">
+      <a:schemeClr val="lt1"/>
+    </dgm:linClrLst>
+    <dgm:effectClrLst/>
+    <dgm:txLinClrLst/>
+    <dgm:txFillClrLst/>
+    <dgm:txEffectClrLst/>
+  </dgm:styleLbl>
+  <dgm:styleLbl name="asst4">
+    <dgm:fillClrLst meth="repeat">
+      <a:schemeClr val="accent1"/>
+    </dgm:fillClrLst>
+    <dgm:linClrLst meth="repeat">
+      <a:schemeClr val="lt1"/>
+    </dgm:linClrLst>
+    <dgm:effectClrLst/>
+    <dgm:txLinClrLst/>
+    <dgm:txFillClrLst/>
+    <dgm:txEffectClrLst/>
+  </dgm:styleLbl>
+  <dgm:styleLbl name="parChTrans2D1">
+    <dgm:fillClrLst meth="repeat">
+      <a:schemeClr val="accent1">
+        <a:tint val="60000"/>
+      </a:schemeClr>
+    </dgm:fillClrLst>
+    <dgm:linClrLst meth="repeat">
+      <a:schemeClr val="accent1">
+        <a:tint val="60000"/>
+      </a:schemeClr>
+    </dgm:linClrLst>
+    <dgm:effectClrLst/>
+    <dgm:txLinClrLst/>
+    <dgm:txFillClrLst meth="repeat">
+      <a:schemeClr val="lt1"/>
+    </dgm:txFillClrLst>
+    <dgm:txEffectClrLst/>
+  </dgm:styleLbl>
+  <dgm:styleLbl name="parChTrans2D2">
+    <dgm:fillClrLst meth="repeat">
+      <a:schemeClr val="accent1"/>
+    </dgm:fillClrLst>
+    <dgm:linClrLst meth="repeat">
+      <a:schemeClr val="accent1"/>
+    </dgm:linClrLst>
+    <dgm:effectClrLst/>
+    <dgm:txLinClrLst/>
+    <dgm:txFillClrLst meth="repeat">
+      <a:schemeClr val="lt1"/>
+    </dgm:txFillClrLst>
+    <dgm:txEffectClrLst/>
+  </dgm:styleLbl>
+  <dgm:styleLbl name="parChTrans2D3">
+    <dgm:fillClrLst meth="repeat">
+      <a:schemeClr val="accent1"/>
+    </dgm:fillClrLst>
+    <dgm:linClrLst meth="repeat">
+      <a:schemeClr val="accent1"/>
+    </dgm:linClrLst>
+    <dgm:effectClrLst/>
+    <dgm:txLinClrLst/>
+    <dgm:txFillClrLst meth="repeat">
+      <a:schemeClr val="lt1"/>
+    </dgm:txFillClrLst>
+    <dgm:txEffectClrLst/>
+  </dgm:styleLbl>
+  <dgm:styleLbl name="parChTrans2D4">
+    <dgm:fillClrLst meth="repeat">
+      <a:schemeClr val="accent1"/>
+    </dgm:fillClrLst>
+    <dgm:linClrLst meth="repeat">
+      <a:schemeClr val="accent1"/>
+    </dgm:linClrLst>
+    <dgm:effectClrLst/>
+    <dgm:txLinClrLst/>
+    <dgm:txFillClrLst meth="repeat">
+      <a:schemeClr val="lt1"/>
+    </dgm:txFillClrLst>
+    <dgm:txEffectClrLst/>
+  </dgm:styleLbl>
+  <dgm:styleLbl name="parChTrans1D1">
+    <dgm:fillClrLst meth="repeat">
+      <a:schemeClr val="accent1"/>
+    </dgm:fillClrLst>
+    <dgm:linClrLst meth="repeat">
+      <a:schemeClr val="accent1">
+        <a:shade val="60000"/>
+      </a:schemeClr>
+    </dgm:linClrLst>
+    <dgm:effectClrLst/>
+    <dgm:txLinClrLst/>
+    <dgm:txFillClrLst meth="repeat">
+      <a:schemeClr val="tx1"/>
+    </dgm:txFillClrLst>
+    <dgm:txEffectClrLst/>
+  </dgm:styleLbl>
+  <dgm:styleLbl name="parChTrans1D2">
+    <dgm:fillClrLst meth="repeat">
+      <a:schemeClr val="accent1"/>
+    </dgm:fillClrLst>
+    <dgm:linClrLst meth="repeat">
+      <a:schemeClr val="accent1">
+        <a:shade val="60000"/>
+      </a:schemeClr>
+    </dgm:linClrLst>
+    <dgm:effectClrLst/>
+    <dgm:txLinClrLst/>
+    <dgm:txFillClrLst meth="repeat">
+      <a:schemeClr val="tx1"/>
+    </dgm:txFillClrLst>
+    <dgm:txEffectClrLst/>
+  </dgm:styleLbl>
+  <dgm:styleLbl name="parChTrans1D3">
+    <dgm:fillClrLst meth="repeat">
+      <a:schemeClr val="accent1"/>
+    </dgm:fillClrLst>
+    <dgm:linClrLst meth="repeat">
+      <a:schemeClr val="accent1">
+        <a:shade val="80000"/>
+      </a:schemeClr>
+    </dgm:linClrLst>
+    <dgm:effectClrLst/>
+    <dgm:txLinClrLst/>
+    <dgm:txFillClrLst meth="repeat">
+      <a:schemeClr val="tx1"/>
+    </dgm:txFillClrLst>
+    <dgm:txEffectClrLst/>
+  </dgm:styleLbl>
+  <dgm:styleLbl name="parChTrans1D4">
+    <dgm:fillClrLst meth="repeat">
+      <a:schemeClr val="accent1"/>
+    </dgm:fillClrLst>
+    <dgm:linClrLst meth="repeat">
+      <a:schemeClr val="accent1">
+        <a:shade val="80000"/>
+      </a:schemeClr>
+    </dgm:linClrLst>
+    <dgm:effectClrLst/>
+    <dgm:txLinClrLst/>
+    <dgm:txFillClrLst meth="repeat">
+      <a:schemeClr val="tx1"/>
+    </dgm:txFillClrLst>
+    <dgm:txEffectClrLst/>
+  </dgm:styleLbl>
+  <dgm:styleLbl name="fgAcc1">
+    <dgm:fillClrLst meth="repeat">
+      <a:schemeClr val="lt1">
+        <a:alpha val="90000"/>
+      </a:schemeClr>
+    </dgm:fillClrLst>
+    <dgm:linClrLst meth="repeat">
+      <a:schemeClr val="accent1"/>
+    </dgm:linClrLst>
+    <dgm:effectClrLst/>
+    <dgm:txLinClrLst/>
+    <dgm:txFillClrLst meth="repeat">
+      <a:schemeClr val="dk1"/>
+    </dgm:txFillClrLst>
+    <dgm:txEffectClrLst/>
+  </dgm:styleLbl>
+  <dgm:styleLbl name="conFgAcc1">
+    <dgm:fillClrLst meth="repeat">
+      <a:schemeClr val="lt1">
+        <a:alpha val="90000"/>
+      </a:schemeClr>
+    </dgm:fillClrLst>
+    <dgm:linClrLst meth="repeat">
+      <a:schemeClr val="accent1"/>
+    </dgm:linClrLst>
+    <dgm:effectClrLst/>
+    <dgm:txLinClrLst/>
+    <dgm:txFillClrLst meth="repeat">
+      <a:schemeClr val="dk1"/>
+    </dgm:txFillClrLst>
+    <dgm:txEffectClrLst/>
+  </dgm:styleLbl>
+  <dgm:styleLbl name="alignAcc1">
+    <dgm:fillClrLst meth="repeat">
+      <a:schemeClr val="lt1">
+        <a:alpha val="90000"/>
+      </a:schemeClr>
+    </dgm:fillClrLst>
+    <dgm:linClrLst meth="repeat">
+      <a:schemeClr val="accent1"/>
+    </dgm:linClrLst>
+    <dgm:effectClrLst/>
+    <dgm:txLinClrLst/>
+    <dgm:txFillClrLst meth="repeat">
+      <a:schemeClr val="dk1"/>
+    </dgm:txFillClrLst>
+    <dgm:txEffectClrLst/>
+  </dgm:styleLbl>
+  <dgm:styleLbl name="trAlignAcc1">
+    <dgm:fillClrLst meth="repeat">
+      <a:schemeClr val="lt1">
+        <a:alpha val="40000"/>
+      </a:schemeClr>
+    </dgm:fillClrLst>
+    <dgm:linClrLst meth="repeat">
+      <a:schemeClr val="accent1"/>
+    </dgm:linClrLst>
+    <dgm:effectClrLst/>
+    <dgm:txLinClrLst/>
+    <dgm:txFillClrLst meth="repeat">
+      <a:schemeClr val="dk1"/>
+    </dgm:txFillClrLst>
+    <dgm:txEffectClrLst/>
+  </dgm:styleLbl>
+  <dgm:styleLbl name="bgAcc1">
+    <dgm:fillClrLst meth="repeat">
+      <a:schemeClr val="lt1">
+        <a:alpha val="90000"/>
+      </a:schemeClr>
+    </dgm:fillClrLst>
+    <dgm:linClrLst meth="repeat">
+      <a:schemeClr val="accent1"/>
+    </dgm:linClrLst>
+    <dgm:effectClrLst/>
+    <dgm:txLinClrLst/>
+    <dgm:txFillClrLst meth="repeat">
+      <a:schemeClr val="dk1"/>
+    </dgm:txFillClrLst>
+    <dgm:txEffectClrLst/>
+  </dgm:styleLbl>
+  <dgm:styleLbl name="solidFgAcc1">
+    <dgm:fillClrLst meth="repeat">
+      <a:schemeClr val="lt1"/>
+    </dgm:fillClrLst>
+    <dgm:linClrLst meth="repeat">
+      <a:schemeClr val="accent1"/>
+    </dgm:linClrLst>
+    <dgm:effectClrLst/>
+    <dgm:txLinClrLst/>
+    <dgm:txFillClrLst meth="repeat">
+      <a:schemeClr val="dk1"/>
+    </dgm:txFillClrLst>
+    <dgm:txEffectClrLst/>
+  </dgm:styleLbl>
+  <dgm:styleLbl name="solidAlignAcc1">
+    <dgm:fillClrLst meth="repeat">
+      <a:schemeClr val="lt1"/>
+    </dgm:fillClrLst>
+    <dgm:linClrLst meth="repeat">
+      <a:schemeClr val="accent1"/>
+    </dgm:linClrLst>
+    <dgm:effectClrLst/>
+    <dgm:txLinClrLst/>
+    <dgm:txFillClrLst meth="repeat">
+      <a:schemeClr val="dk1"/>
+    </dgm:txFillClrLst>
+    <dgm:txEffectClrLst/>
+  </dgm:styleLbl>
+  <dgm:styleLbl name="solidBgAcc1">
+    <dgm:fillClrLst meth="repeat">
+      <a:schemeClr val="lt1"/>
+    </dgm:fillClrLst>
+    <dgm:linClrLst meth="repeat">
+      <a:schemeClr val="accent1"/>
+    </dgm:linClrLst>
+    <dgm:effectClrLst/>
+    <dgm:txLinClrLst/>
+    <dgm:txFillClrLst meth="repeat">
+      <a:schemeClr val="dk1"/>
+    </dgm:txFillClrLst>
+    <dgm:txEffectClrLst/>
+  </dgm:styleLbl>
+  <dgm:styleLbl name="fgAccFollowNode1">
+    <dgm:fillClrLst meth="repeat">
+      <a:schemeClr val="accent1">
+        <a:alpha val="90000"/>
+        <a:tint val="40000"/>
+      </a:schemeClr>
+    </dgm:fillClrLst>
+    <dgm:linClrLst meth="repeat">
+      <a:schemeClr val="accent1">
+        <a:alpha val="90000"/>
+        <a:tint val="40000"/>
+      </a:schemeClr>
+    </dgm:linClrLst>
+    <dgm:effectClrLst/>
+    <dgm:txLinClrLst/>
+    <dgm:txFillClrLst meth="repeat">
+      <a:schemeClr val="dk1"/>
+    </dgm:txFillClrLst>
+    <dgm:txEffectClrLst/>
+  </dgm:styleLbl>
+  <dgm:styleLbl name="alignAccFollowNode1">
+    <dgm:fillClrLst meth="repeat">
+      <a:schemeClr val="accent1">
+        <a:alpha val="90000"/>
+        <a:tint val="40000"/>
+      </a:schemeClr>
+    </dgm:fillClrLst>
+    <dgm:linClrLst meth="repeat">
+      <a:schemeClr val="accent1">
+        <a:alpha val="90000"/>
+        <a:tint val="40000"/>
+      </a:schemeClr>
+    </dgm:linClrLst>
+    <dgm:effectClrLst/>
+    <dgm:txLinClrLst/>
+    <dgm:txFillClrLst meth="repeat">
+      <a:schemeClr val="dk1"/>
+    </dgm:txFillClrLst>
+    <dgm:txEffectClrLst/>
+  </dgm:styleLbl>
+  <dgm:styleLbl name="bgAccFollowNode1">
+    <dgm:fillClrLst meth="repeat">
+      <a:schemeClr val="accent1">
+        <a:alpha val="90000"/>
+        <a:tint val="40000"/>
+      </a:schemeClr>
+    </dgm:fillClrLst>
+    <dgm:linClrLst meth="repeat">
+      <a:schemeClr val="accent1">
+        <a:alpha val="90000"/>
+        <a:tint val="40000"/>
+      </a:schemeClr>
+    </dgm:linClrLst>
+    <dgm:effectClrLst/>
+    <dgm:txLinClrLst/>
+    <dgm:txFillClrLst meth="repeat">
+      <a:schemeClr val="dk1"/>
+    </dgm:txFillClrLst>
+    <dgm:txEffectClrLst/>
+  </dgm:styleLbl>
+  <dgm:styleLbl name="fgAcc0">
+    <dgm:fillClrLst meth="repeat">
+      <a:schemeClr val="lt1">
+        <a:alpha val="90000"/>
+      </a:schemeClr>
+    </dgm:fillClrLst>
+    <dgm:linClrLst meth="repeat">
+      <a:schemeClr val="accent1"/>
+    </dgm:linClrLst>
+    <dgm:effectClrLst/>
+    <dgm:txLinClrLst/>
+    <dgm:txFillClrLst meth="repeat">
+      <a:schemeClr val="dk1"/>
+    </dgm:txFillClrLst>
+    <dgm:txEffectClrLst/>
+  </dgm:styleLbl>
+  <dgm:styleLbl name="fgAcc2">
+    <dgm:fillClrLst meth="repeat">
+      <a:schemeClr val="lt1">
+        <a:alpha val="90000"/>
+      </a:schemeClr>
+    </dgm:fillClrLst>
+    <dgm:linClrLst meth="repeat">
+      <a:schemeClr val="accent1"/>
+    </dgm:linClrLst>
+    <dgm:effectClrLst/>
+    <dgm:txLinClrLst/>
+    <dgm:txFillClrLst meth="repeat">
+      <a:schemeClr val="dk1"/>
+    </dgm:txFillClrLst>
+    <dgm:txEffectClrLst/>
+  </dgm:styleLbl>
+  <dgm:styleLbl name="fgAcc3">
+    <dgm:fillClrLst meth="repeat">
+      <a:schemeClr val="lt1">
+        <a:alpha val="90000"/>
+      </a:schemeClr>
+    </dgm:fillClrLst>
+    <dgm:linClrLst meth="repeat">
+      <a:schemeClr val="accent1"/>
+    </dgm:linClrLst>
+    <dgm:effectClrLst/>
+    <dgm:txLinClrLst/>
+    <dgm:txFillClrLst meth="repeat">
+      <a:schemeClr val="dk1"/>
+    </dgm:txFillClrLst>
+    <dgm:txEffectClrLst/>
+  </dgm:styleLbl>
+  <dgm:styleLbl name="fgAcc4">
+    <dgm:fillClrLst meth="repeat">
+      <a:schemeClr val="lt1">
+        <a:alpha val="90000"/>
+      </a:schemeClr>
+    </dgm:fillClrLst>
+    <dgm:linClrLst meth="repeat">
+      <a:schemeClr val="accent1"/>
+    </dgm:linClrLst>
+    <dgm:effectClrLst/>
+    <dgm:txLinClrLst/>
+    <dgm:txFillClrLst meth="repeat">
+      <a:schemeClr val="dk1"/>
+    </dgm:txFillClrLst>
+    <dgm:txEffectClrLst/>
+  </dgm:styleLbl>
+  <dgm:styleLbl name="bgShp">
+    <dgm:fillClrLst meth="repeat">
+      <a:schemeClr val="accent1">
+        <a:tint val="40000"/>
+      </a:schemeClr>
+    </dgm:fillClrLst>
+    <dgm:linClrLst meth="repeat">
+      <a:schemeClr val="accent1"/>
+    </dgm:linClrLst>
+    <dgm:effectClrLst/>
+    <dgm:txLinClrLst/>
+    <dgm:txFillClrLst meth="repeat">
+      <a:schemeClr val="dk1"/>
+    </dgm:txFillClrLst>
+    <dgm:txEffectClrLst/>
+  </dgm:styleLbl>
+  <dgm:styleLbl name="dkBgShp">
+    <dgm:fillClrLst meth="repeat">
+      <a:schemeClr val="accent1">
+        <a:shade val="80000"/>
+      </a:schemeClr>
+    </dgm:fillClrLst>
+    <dgm:linClrLst meth="repeat">
+      <a:schemeClr val="accent1"/>
+    </dgm:linClrLst>
+    <dgm:effectClrLst/>
+    <dgm:txLinClrLst/>
+    <dgm:txFillClrLst meth="repeat">
+      <a:schemeClr val="lt1"/>
+    </dgm:txFillClrLst>
+    <dgm:txEffectClrLst/>
+  </dgm:styleLbl>
+  <dgm:styleLbl name="trBgShp">
+    <dgm:fillClrLst meth="repeat">
+      <a:schemeClr val="accent1">
+        <a:tint val="50000"/>
+        <a:alpha val="40000"/>
+      </a:schemeClr>
+    </dgm:fillClrLst>
+    <dgm:linClrLst meth="repeat">
+      <a:schemeClr val="accent1"/>
+    </dgm:linClrLst>
+    <dgm:effectClrLst/>
+    <dgm:txLinClrLst/>
+    <dgm:txFillClrLst meth="repeat">
+      <a:schemeClr val="lt1"/>
+    </dgm:txFillClrLst>
+    <dgm:txEffectClrLst/>
+  </dgm:styleLbl>
+  <dgm:styleLbl name="fgShp">
+    <dgm:fillClrLst meth="repeat">
+      <a:schemeClr val="accent1">
+        <a:tint val="60000"/>
+      </a:schemeClr>
+    </dgm:fillClrLst>
+    <dgm:linClrLst meth="repeat">
+      <a:schemeClr val="lt1"/>
+    </dgm:linClrLst>
+    <dgm:effectClrLst/>
+    <dgm:txLinClrLst/>
+    <dgm:txFillClrLst meth="repeat">
+      <a:schemeClr val="dk1"/>
+    </dgm:txFillClrLst>
+    <dgm:txEffectClrLst/>
+  </dgm:styleLbl>
+  <dgm:styleLbl name="revTx">
+    <dgm:fillClrLst meth="repeat">
+      <a:schemeClr val="lt1">
+        <a:alpha val="0"/>
+      </a:schemeClr>
+    </dgm:fillClrLst>
+    <dgm:linClrLst meth="repeat">
+      <a:schemeClr val="dk1">
+        <a:alpha val="0"/>
+      </a:schemeClr>
+    </dgm:linClrLst>
+    <dgm:effectClrLst/>
+    <dgm:txLinClrLst/>
+    <dgm:txFillClrLst meth="repeat">
+      <a:schemeClr val="tx1"/>
+    </dgm:txFillClrLst>
+    <dgm:txEffectClrLst/>
+  </dgm:styleLbl>
+</dgm:colorsDef>
+</file>
+
+<file path=ppt/diagrams/data1.xml><?xml version="1.0" encoding="utf-8"?>
+<dgm:dataModel xmlns:dgm="http://schemas.openxmlformats.org/drawingml/2006/diagram" xmlns:a="http://schemas.openxmlformats.org/drawingml/2006/main">
+  <dgm:ptLst>
+    <dgm:pt modelId="{26A7AE75-0476-574B-AA09-6F2F478FD701}" type="doc">
+      <dgm:prSet loTypeId="urn:microsoft.com/office/officeart/2005/8/layout/vList3" loCatId="" qsTypeId="urn:microsoft.com/office/officeart/2005/8/quickstyle/simple1" qsCatId="simple" csTypeId="urn:microsoft.com/office/officeart/2005/8/colors/accent1_2" csCatId="accent1" phldr="1"/>
+      <dgm:spPr/>
+      <dgm:t>
+        <a:bodyPr/>
+        <a:lstStyle/>
+        <a:p>
+          <a:endParaRPr lang="en-GB"/>
+        </a:p>
+      </dgm:t>
+    </dgm:pt>
+    <dgm:pt modelId="{B12428B0-2182-EE43-802E-980A13773010}">
+      <dgm:prSet phldrT="[Text]"/>
+      <dgm:spPr>
+        <a:solidFill>
+          <a:srgbClr val="46A01E"/>
+        </a:solidFill>
+      </dgm:spPr>
+      <dgm:t>
+        <a:bodyPr/>
+        <a:lstStyle/>
+        <a:p>
+          <a:r>
+            <a:rPr lang="en-GB" dirty="0" err="1"/>
+            <a:t>Contesto</a:t>
+          </a:r>
+          <a:r>
+            <a:rPr lang="en-GB" dirty="0"/>
+            <a:t> e </a:t>
+          </a:r>
+          <a:r>
+            <a:rPr lang="en-GB" dirty="0" err="1"/>
+            <a:t>Motivazione</a:t>
+          </a:r>
+          <a:endParaRPr lang="en-GB" dirty="0"/>
+        </a:p>
+      </dgm:t>
+    </dgm:pt>
+    <dgm:pt modelId="{44BDDF78-447B-F54B-BA4C-11EDCF71A381}" type="parTrans" cxnId="{357C5714-D58E-524C-AE4E-DA0120D618F1}">
+      <dgm:prSet/>
+      <dgm:spPr/>
+      <dgm:t>
+        <a:bodyPr/>
+        <a:lstStyle/>
+        <a:p>
+          <a:endParaRPr lang="en-GB"/>
+        </a:p>
+      </dgm:t>
+    </dgm:pt>
+    <dgm:pt modelId="{726318FE-D79E-7E42-988D-2A42010ADF0B}" type="sibTrans" cxnId="{357C5714-D58E-524C-AE4E-DA0120D618F1}">
+      <dgm:prSet/>
+      <dgm:spPr/>
+      <dgm:t>
+        <a:bodyPr/>
+        <a:lstStyle/>
+        <a:p>
+          <a:endParaRPr lang="en-GB"/>
+        </a:p>
+      </dgm:t>
+    </dgm:pt>
+    <dgm:pt modelId="{CA297D3B-B492-3940-8FCA-CBA149942607}">
+      <dgm:prSet phldrT="[Text]"/>
+      <dgm:spPr>
+        <a:solidFill>
+          <a:srgbClr val="58A322"/>
+        </a:solidFill>
+      </dgm:spPr>
+      <dgm:t>
+        <a:bodyPr/>
+        <a:lstStyle/>
+        <a:p>
+          <a:r>
+            <a:rPr lang="en-GB" dirty="0" err="1"/>
+            <a:t>Obbiettivo</a:t>
+          </a:r>
+          <a:endParaRPr lang="en-GB" dirty="0"/>
+        </a:p>
+      </dgm:t>
+    </dgm:pt>
+    <dgm:pt modelId="{3251D0AF-80B8-A047-B30C-EC5020A48052}" type="parTrans" cxnId="{CA57CF6A-314A-1D46-9554-D53A98D7760E}">
+      <dgm:prSet/>
+      <dgm:spPr/>
+      <dgm:t>
+        <a:bodyPr/>
+        <a:lstStyle/>
+        <a:p>
+          <a:endParaRPr lang="en-GB"/>
+        </a:p>
+      </dgm:t>
+    </dgm:pt>
+    <dgm:pt modelId="{8E6652C2-C9F4-0349-8223-BFB37697181E}" type="sibTrans" cxnId="{CA57CF6A-314A-1D46-9554-D53A98D7760E}">
+      <dgm:prSet/>
+      <dgm:spPr/>
+      <dgm:t>
+        <a:bodyPr/>
+        <a:lstStyle/>
+        <a:p>
+          <a:endParaRPr lang="en-GB"/>
+        </a:p>
+      </dgm:t>
+    </dgm:pt>
+    <dgm:pt modelId="{2DE3E10C-D72F-7B4C-AE2B-3FE8F124C95A}">
+      <dgm:prSet phldrT="[Text]"/>
+      <dgm:spPr>
+        <a:solidFill>
+          <a:srgbClr val="61A424"/>
+        </a:solidFill>
+      </dgm:spPr>
+      <dgm:t>
+        <a:bodyPr/>
+        <a:lstStyle/>
+        <a:p>
+          <a:r>
+            <a:rPr lang="en-GB" dirty="0" err="1"/>
+            <a:t>Problemi</a:t>
+          </a:r>
+          <a:endParaRPr lang="en-GB" dirty="0"/>
+        </a:p>
+      </dgm:t>
+    </dgm:pt>
+    <dgm:pt modelId="{784A0237-5093-3148-B872-372294A5D6F2}" type="parTrans" cxnId="{64F761C0-E4FA-7D43-8F65-087CE1EFABE8}">
+      <dgm:prSet/>
+      <dgm:spPr/>
+      <dgm:t>
+        <a:bodyPr/>
+        <a:lstStyle/>
+        <a:p>
+          <a:endParaRPr lang="en-GB"/>
+        </a:p>
+      </dgm:t>
+    </dgm:pt>
+    <dgm:pt modelId="{94FBFFAF-9DE0-154E-BFAB-6172F171FBFC}" type="sibTrans" cxnId="{64F761C0-E4FA-7D43-8F65-087CE1EFABE8}">
+      <dgm:prSet/>
+      <dgm:spPr/>
+      <dgm:t>
+        <a:bodyPr/>
+        <a:lstStyle/>
+        <a:p>
+          <a:endParaRPr lang="en-GB"/>
+        </a:p>
+      </dgm:t>
+    </dgm:pt>
+    <dgm:pt modelId="{568C78F9-C35A-A14E-9821-A3D78CFB2934}">
+      <dgm:prSet/>
+      <dgm:spPr>
+        <a:solidFill>
+          <a:srgbClr val="6AA525"/>
+        </a:solidFill>
+      </dgm:spPr>
+      <dgm:t>
+        <a:bodyPr/>
+        <a:lstStyle/>
+        <a:p>
+          <a:r>
+            <a:rPr lang="en-GB" dirty="0"/>
+            <a:t>Stato dell’arte</a:t>
+          </a:r>
+        </a:p>
+      </dgm:t>
+    </dgm:pt>
+    <dgm:pt modelId="{A63D79F8-F5B5-2C4F-A017-A9A65BD9DDDD}" type="parTrans" cxnId="{6A85E54F-58C6-4647-B919-C14FB80F1FF5}">
+      <dgm:prSet/>
+      <dgm:spPr/>
+      <dgm:t>
+        <a:bodyPr/>
+        <a:lstStyle/>
+        <a:p>
+          <a:endParaRPr lang="en-GB"/>
+        </a:p>
+      </dgm:t>
+    </dgm:pt>
+    <dgm:pt modelId="{EAB264E4-6AD6-5D41-A46A-4AB73D1FCBB8}" type="sibTrans" cxnId="{6A85E54F-58C6-4647-B919-C14FB80F1FF5}">
+      <dgm:prSet/>
+      <dgm:spPr/>
+      <dgm:t>
+        <a:bodyPr/>
+        <a:lstStyle/>
+        <a:p>
+          <a:endParaRPr lang="en-GB"/>
+        </a:p>
+      </dgm:t>
+    </dgm:pt>
+    <dgm:pt modelId="{13B2C432-C4FC-D44C-8FF5-ED24902ADD08}">
+      <dgm:prSet/>
+      <dgm:spPr>
+        <a:solidFill>
+          <a:srgbClr val="73B12B"/>
+        </a:solidFill>
+      </dgm:spPr>
+      <dgm:t>
+        <a:bodyPr/>
+        <a:lstStyle/>
+        <a:p>
+          <a:r>
+            <a:rPr lang="en-GB" dirty="0" err="1"/>
+            <a:t>Approccio</a:t>
+          </a:r>
+          <a:endParaRPr lang="en-GB" dirty="0"/>
+        </a:p>
+      </dgm:t>
+    </dgm:pt>
+    <dgm:pt modelId="{769C505A-2566-3040-80B5-CE3FF5DB4EE3}" type="parTrans" cxnId="{FAD9D88F-FBF4-A74D-A12A-C50515C0B91C}">
+      <dgm:prSet/>
+      <dgm:spPr/>
+      <dgm:t>
+        <a:bodyPr/>
+        <a:lstStyle/>
+        <a:p>
+          <a:endParaRPr lang="en-GB"/>
+        </a:p>
+      </dgm:t>
+    </dgm:pt>
+    <dgm:pt modelId="{DDAA1F0A-ECA1-C24E-A2C6-761C9D0861C8}" type="sibTrans" cxnId="{FAD9D88F-FBF4-A74D-A12A-C50515C0B91C}">
+      <dgm:prSet/>
+      <dgm:spPr/>
+      <dgm:t>
+        <a:bodyPr/>
+        <a:lstStyle/>
+        <a:p>
+          <a:endParaRPr lang="en-GB"/>
+        </a:p>
+      </dgm:t>
+    </dgm:pt>
+    <dgm:pt modelId="{4753B252-6A65-5F4A-8734-5CBB42DC366E}">
+      <dgm:prSet/>
+      <dgm:spPr>
+        <a:solidFill>
+          <a:srgbClr val="7BBC31"/>
+        </a:solidFill>
+      </dgm:spPr>
+      <dgm:t>
+        <a:bodyPr/>
+        <a:lstStyle/>
+        <a:p>
+          <a:r>
+            <a:rPr lang="en-GB" dirty="0" err="1"/>
+            <a:t>Risultato</a:t>
+          </a:r>
+          <a:endParaRPr lang="en-GB" dirty="0"/>
+        </a:p>
+      </dgm:t>
+    </dgm:pt>
+    <dgm:pt modelId="{DFD48EE3-EBB1-DC49-9DB3-7BDC79288494}" type="parTrans" cxnId="{E48857CC-210E-304C-B7B5-1FE9216230DD}">
+      <dgm:prSet/>
+      <dgm:spPr/>
+      <dgm:t>
+        <a:bodyPr/>
+        <a:lstStyle/>
+        <a:p>
+          <a:endParaRPr lang="en-GB"/>
+        </a:p>
+      </dgm:t>
+    </dgm:pt>
+    <dgm:pt modelId="{F695F43A-8C5A-764A-A333-4A81E5C6721F}" type="sibTrans" cxnId="{E48857CC-210E-304C-B7B5-1FE9216230DD}">
+      <dgm:prSet/>
+      <dgm:spPr/>
+      <dgm:t>
+        <a:bodyPr/>
+        <a:lstStyle/>
+        <a:p>
+          <a:endParaRPr lang="en-GB"/>
+        </a:p>
+      </dgm:t>
+    </dgm:pt>
+    <dgm:pt modelId="{09DC5A73-DAD8-744A-BBEE-F90F6E5625BE}">
+      <dgm:prSet/>
+      <dgm:spPr>
+        <a:solidFill>
+          <a:schemeClr val="accent6"/>
+        </a:solidFill>
+      </dgm:spPr>
+      <dgm:t>
+        <a:bodyPr/>
+        <a:lstStyle/>
+        <a:p>
+          <a:r>
+            <a:rPr lang="en-GB" dirty="0" err="1"/>
+            <a:t>Conclusioni</a:t>
+          </a:r>
+          <a:endParaRPr lang="en-GB" dirty="0"/>
+        </a:p>
+      </dgm:t>
+    </dgm:pt>
+    <dgm:pt modelId="{9F20319B-9D09-F541-A427-9D2B2B0ABB0F}" type="parTrans" cxnId="{B1F6E567-4D84-D045-8B88-9B8339374F78}">
+      <dgm:prSet/>
+      <dgm:spPr/>
+      <dgm:t>
+        <a:bodyPr/>
+        <a:lstStyle/>
+        <a:p>
+          <a:endParaRPr lang="en-GB"/>
+        </a:p>
+      </dgm:t>
+    </dgm:pt>
+    <dgm:pt modelId="{98719CC5-A5AD-EE4D-A3F4-0847874471C7}" type="sibTrans" cxnId="{B1F6E567-4D84-D045-8B88-9B8339374F78}">
+      <dgm:prSet/>
+      <dgm:spPr/>
+      <dgm:t>
+        <a:bodyPr/>
+        <a:lstStyle/>
+        <a:p>
+          <a:endParaRPr lang="en-GB"/>
+        </a:p>
+      </dgm:t>
+    </dgm:pt>
+    <dgm:pt modelId="{1E14DD05-72DC-444B-9BEE-0593C9B5AB8C}" type="pres">
+      <dgm:prSet presAssocID="{26A7AE75-0476-574B-AA09-6F2F478FD701}" presName="linearFlow" presStyleCnt="0">
+        <dgm:presLayoutVars>
+          <dgm:dir/>
+          <dgm:resizeHandles val="exact"/>
+        </dgm:presLayoutVars>
+      </dgm:prSet>
+      <dgm:spPr/>
+    </dgm:pt>
+    <dgm:pt modelId="{BE3924EC-FCE2-1544-A1E7-55651C31AAD4}" type="pres">
+      <dgm:prSet presAssocID="{B12428B0-2182-EE43-802E-980A13773010}" presName="composite" presStyleCnt="0"/>
+      <dgm:spPr/>
+    </dgm:pt>
+    <dgm:pt modelId="{3921451E-7F44-7148-8564-DD0161AD58D7}" type="pres">
+      <dgm:prSet presAssocID="{B12428B0-2182-EE43-802E-980A13773010}" presName="imgShp" presStyleLbl="fgImgPlace1" presStyleIdx="0" presStyleCnt="7" custLinFactX="-100000" custLinFactNeighborX="-175079" custLinFactNeighborY="-90"/>
+      <dgm:spPr>
+        <a:solidFill>
+          <a:schemeClr val="accent6">
+            <a:lumMod val="20000"/>
+            <a:lumOff val="80000"/>
+          </a:schemeClr>
+        </a:solidFill>
+      </dgm:spPr>
+    </dgm:pt>
+    <dgm:pt modelId="{67BCFC79-616B-4A47-83A6-5582B700891C}" type="pres">
+      <dgm:prSet presAssocID="{B12428B0-2182-EE43-802E-980A13773010}" presName="txShp" presStyleLbl="node1" presStyleIdx="0" presStyleCnt="7" custScaleX="150376">
+        <dgm:presLayoutVars>
+          <dgm:bulletEnabled val="1"/>
+        </dgm:presLayoutVars>
+      </dgm:prSet>
+      <dgm:spPr/>
+    </dgm:pt>
+    <dgm:pt modelId="{D86CB79A-06EE-904F-BDCF-74BE76332FE8}" type="pres">
+      <dgm:prSet presAssocID="{726318FE-D79E-7E42-988D-2A42010ADF0B}" presName="spacing" presStyleCnt="0"/>
+      <dgm:spPr/>
+    </dgm:pt>
+    <dgm:pt modelId="{B707F65D-5A3B-9347-A5EC-D2B55FA47346}" type="pres">
+      <dgm:prSet presAssocID="{CA297D3B-B492-3940-8FCA-CBA149942607}" presName="composite" presStyleCnt="0"/>
+      <dgm:spPr/>
+    </dgm:pt>
+    <dgm:pt modelId="{5E287AE0-B3FA-0E44-BC11-C841BAE2CDD2}" type="pres">
+      <dgm:prSet presAssocID="{CA297D3B-B492-3940-8FCA-CBA149942607}" presName="imgShp" presStyleLbl="fgImgPlace1" presStyleIdx="1" presStyleCnt="7" custLinFactX="-100000" custLinFactNeighborX="-192670" custLinFactNeighborY="92"/>
+      <dgm:spPr>
+        <a:solidFill>
+          <a:schemeClr val="accent6">
+            <a:lumMod val="20000"/>
+            <a:lumOff val="80000"/>
+          </a:schemeClr>
+        </a:solidFill>
+      </dgm:spPr>
+    </dgm:pt>
+    <dgm:pt modelId="{F9462253-E1A8-734A-A481-5054139885B1}" type="pres">
+      <dgm:prSet presAssocID="{CA297D3B-B492-3940-8FCA-CBA149942607}" presName="txShp" presStyleLbl="node1" presStyleIdx="1" presStyleCnt="7" custScaleX="150376" custScaleY="100256">
+        <dgm:presLayoutVars>
+          <dgm:bulletEnabled val="1"/>
+        </dgm:presLayoutVars>
+      </dgm:prSet>
+      <dgm:spPr/>
+    </dgm:pt>
+    <dgm:pt modelId="{173D2260-5B6B-EC43-A5C0-4B4F815E7D1A}" type="pres">
+      <dgm:prSet presAssocID="{8E6652C2-C9F4-0349-8223-BFB37697181E}" presName="spacing" presStyleCnt="0"/>
+      <dgm:spPr/>
+    </dgm:pt>
+    <dgm:pt modelId="{BD09F5A7-5FA7-1643-A1C9-F3176F458A6B}" type="pres">
+      <dgm:prSet presAssocID="{2DE3E10C-D72F-7B4C-AE2B-3FE8F124C95A}" presName="composite" presStyleCnt="0"/>
+      <dgm:spPr/>
+    </dgm:pt>
+    <dgm:pt modelId="{4C50786B-B7A0-7847-90D2-9E082AAFCF33}" type="pres">
+      <dgm:prSet presAssocID="{2DE3E10C-D72F-7B4C-AE2B-3FE8F124C95A}" presName="imgShp" presStyleLbl="fgImgPlace1" presStyleIdx="2" presStyleCnt="7" custLinFactX="-100000" custLinFactNeighborX="-192670" custLinFactNeighborY="92"/>
+      <dgm:spPr>
+        <a:solidFill>
+          <a:schemeClr val="accent6">
+            <a:lumMod val="20000"/>
+            <a:lumOff val="80000"/>
+          </a:schemeClr>
+        </a:solidFill>
+      </dgm:spPr>
+    </dgm:pt>
+    <dgm:pt modelId="{A17083A3-4A5E-2D43-8A6F-6059B514B65D}" type="pres">
+      <dgm:prSet presAssocID="{2DE3E10C-D72F-7B4C-AE2B-3FE8F124C95A}" presName="txShp" presStyleLbl="node1" presStyleIdx="2" presStyleCnt="7" custScaleX="150376">
+        <dgm:presLayoutVars>
+          <dgm:bulletEnabled val="1"/>
+        </dgm:presLayoutVars>
+      </dgm:prSet>
+      <dgm:spPr/>
+    </dgm:pt>
+    <dgm:pt modelId="{5AAFC7F4-B3FD-AD47-8789-DBDD4FD3F7B8}" type="pres">
+      <dgm:prSet presAssocID="{94FBFFAF-9DE0-154E-BFAB-6172F171FBFC}" presName="spacing" presStyleCnt="0"/>
+      <dgm:spPr/>
+    </dgm:pt>
+    <dgm:pt modelId="{821EA1C5-A0B2-7D41-AC4D-BB8262AE5A56}" type="pres">
+      <dgm:prSet presAssocID="{568C78F9-C35A-A14E-9821-A3D78CFB2934}" presName="composite" presStyleCnt="0"/>
+      <dgm:spPr/>
+    </dgm:pt>
+    <dgm:pt modelId="{1329C8F6-9AB5-6E42-8B22-1D9F87A0AD93}" type="pres">
+      <dgm:prSet presAssocID="{568C78F9-C35A-A14E-9821-A3D78CFB2934}" presName="imgShp" presStyleLbl="fgImgPlace1" presStyleIdx="3" presStyleCnt="7" custLinFactX="-100000" custLinFactNeighborX="-192670" custLinFactNeighborY="92"/>
+      <dgm:spPr>
+        <a:solidFill>
+          <a:schemeClr val="accent6">
+            <a:lumMod val="20000"/>
+            <a:lumOff val="80000"/>
+          </a:schemeClr>
+        </a:solidFill>
+      </dgm:spPr>
+    </dgm:pt>
+    <dgm:pt modelId="{B45F0CEB-30D1-F74B-834A-A5905852DEB6}" type="pres">
+      <dgm:prSet presAssocID="{568C78F9-C35A-A14E-9821-A3D78CFB2934}" presName="txShp" presStyleLbl="node1" presStyleIdx="3" presStyleCnt="7" custScaleX="150376">
+        <dgm:presLayoutVars>
+          <dgm:bulletEnabled val="1"/>
+        </dgm:presLayoutVars>
+      </dgm:prSet>
+      <dgm:spPr/>
+    </dgm:pt>
+    <dgm:pt modelId="{538EBA98-9637-DC4D-9362-6B88A1997EA3}" type="pres">
+      <dgm:prSet presAssocID="{EAB264E4-6AD6-5D41-A46A-4AB73D1FCBB8}" presName="spacing" presStyleCnt="0"/>
+      <dgm:spPr/>
+    </dgm:pt>
+    <dgm:pt modelId="{015FE6EF-7894-4E4D-87C9-1D78F8487627}" type="pres">
+      <dgm:prSet presAssocID="{13B2C432-C4FC-D44C-8FF5-ED24902ADD08}" presName="composite" presStyleCnt="0"/>
+      <dgm:spPr/>
+    </dgm:pt>
+    <dgm:pt modelId="{68174192-DC14-B44E-8134-DC8F2915521D}" type="pres">
+      <dgm:prSet presAssocID="{13B2C432-C4FC-D44C-8FF5-ED24902ADD08}" presName="imgShp" presStyleLbl="fgImgPlace1" presStyleIdx="4" presStyleCnt="7" custLinFactX="-100000" custLinFactNeighborX="-192670" custLinFactNeighborY="92"/>
+      <dgm:spPr>
+        <a:solidFill>
+          <a:schemeClr val="accent6">
+            <a:lumMod val="20000"/>
+            <a:lumOff val="80000"/>
+          </a:schemeClr>
+        </a:solidFill>
+      </dgm:spPr>
+    </dgm:pt>
+    <dgm:pt modelId="{F7C2925B-D97D-F641-A653-47CAD8E1C38F}" type="pres">
+      <dgm:prSet presAssocID="{13B2C432-C4FC-D44C-8FF5-ED24902ADD08}" presName="txShp" presStyleLbl="node1" presStyleIdx="4" presStyleCnt="7" custScaleX="150376">
+        <dgm:presLayoutVars>
+          <dgm:bulletEnabled val="1"/>
+        </dgm:presLayoutVars>
+      </dgm:prSet>
+      <dgm:spPr/>
+    </dgm:pt>
+    <dgm:pt modelId="{1460DDEB-70D3-934B-B8C7-0A60BFBF2D7A}" type="pres">
+      <dgm:prSet presAssocID="{DDAA1F0A-ECA1-C24E-A2C6-761C9D0861C8}" presName="spacing" presStyleCnt="0"/>
+      <dgm:spPr/>
+    </dgm:pt>
+    <dgm:pt modelId="{C594405A-C05D-3740-9D3D-445388FAD988}" type="pres">
+      <dgm:prSet presAssocID="{4753B252-6A65-5F4A-8734-5CBB42DC366E}" presName="composite" presStyleCnt="0"/>
+      <dgm:spPr/>
+    </dgm:pt>
+    <dgm:pt modelId="{92394F4F-528D-384C-B61D-61490A740255}" type="pres">
+      <dgm:prSet presAssocID="{4753B252-6A65-5F4A-8734-5CBB42DC366E}" presName="imgShp" presStyleLbl="fgImgPlace1" presStyleIdx="5" presStyleCnt="7" custLinFactX="-100000" custLinFactNeighborX="-192670" custLinFactNeighborY="92"/>
+      <dgm:spPr>
+        <a:solidFill>
+          <a:schemeClr val="accent6">
+            <a:lumMod val="20000"/>
+            <a:lumOff val="80000"/>
+          </a:schemeClr>
+        </a:solidFill>
+      </dgm:spPr>
+    </dgm:pt>
+    <dgm:pt modelId="{5D925EB2-B21E-724D-A7BD-31301F182B83}" type="pres">
+      <dgm:prSet presAssocID="{4753B252-6A65-5F4A-8734-5CBB42DC366E}" presName="txShp" presStyleLbl="node1" presStyleIdx="5" presStyleCnt="7" custScaleX="150376">
+        <dgm:presLayoutVars>
+          <dgm:bulletEnabled val="1"/>
+        </dgm:presLayoutVars>
+      </dgm:prSet>
+      <dgm:spPr/>
+    </dgm:pt>
+    <dgm:pt modelId="{C981361A-2C19-9C49-985B-50CC11175B16}" type="pres">
+      <dgm:prSet presAssocID="{F695F43A-8C5A-764A-A333-4A81E5C6721F}" presName="spacing" presStyleCnt="0"/>
+      <dgm:spPr/>
+    </dgm:pt>
+    <dgm:pt modelId="{B125B05E-6F6C-244B-B801-BBDBF1FD9F4E}" type="pres">
+      <dgm:prSet presAssocID="{09DC5A73-DAD8-744A-BBEE-F90F6E5625BE}" presName="composite" presStyleCnt="0"/>
+      <dgm:spPr/>
+    </dgm:pt>
+    <dgm:pt modelId="{3B5A8344-2F5A-DE49-97B1-00D7C60CFA26}" type="pres">
+      <dgm:prSet presAssocID="{09DC5A73-DAD8-744A-BBEE-F90F6E5625BE}" presName="imgShp" presStyleLbl="fgImgPlace1" presStyleIdx="6" presStyleCnt="7" custLinFactX="-100000" custLinFactNeighborX="-192670" custLinFactNeighborY="91"/>
+      <dgm:spPr>
+        <a:solidFill>
+          <a:schemeClr val="accent6">
+            <a:lumMod val="20000"/>
+            <a:lumOff val="80000"/>
+          </a:schemeClr>
+        </a:solidFill>
+      </dgm:spPr>
+    </dgm:pt>
+    <dgm:pt modelId="{C414799E-A0D9-6C41-99BF-D5053E4B3D14}" type="pres">
+      <dgm:prSet presAssocID="{09DC5A73-DAD8-744A-BBEE-F90F6E5625BE}" presName="txShp" presStyleLbl="node1" presStyleIdx="6" presStyleCnt="7" custScaleX="150376">
+        <dgm:presLayoutVars>
+          <dgm:bulletEnabled val="1"/>
+        </dgm:presLayoutVars>
+      </dgm:prSet>
+      <dgm:spPr/>
+    </dgm:pt>
+  </dgm:ptLst>
+  <dgm:cxnLst>
+    <dgm:cxn modelId="{97F72C08-DE69-6A43-90FF-95DFFE0BAD17}" type="presOf" srcId="{CA297D3B-B492-3940-8FCA-CBA149942607}" destId="{F9462253-E1A8-734A-A481-5054139885B1}" srcOrd="0" destOrd="0" presId="urn:microsoft.com/office/officeart/2005/8/layout/vList3"/>
+    <dgm:cxn modelId="{357C5714-D58E-524C-AE4E-DA0120D618F1}" srcId="{26A7AE75-0476-574B-AA09-6F2F478FD701}" destId="{B12428B0-2182-EE43-802E-980A13773010}" srcOrd="0" destOrd="0" parTransId="{44BDDF78-447B-F54B-BA4C-11EDCF71A381}" sibTransId="{726318FE-D79E-7E42-988D-2A42010ADF0B}"/>
+    <dgm:cxn modelId="{1315DF3B-30FE-144B-899F-BBCB9BB4A259}" type="presOf" srcId="{B12428B0-2182-EE43-802E-980A13773010}" destId="{67BCFC79-616B-4A47-83A6-5582B700891C}" srcOrd="0" destOrd="0" presId="urn:microsoft.com/office/officeart/2005/8/layout/vList3"/>
+    <dgm:cxn modelId="{56BC8741-D63B-E74B-BB03-EBAD4EA3D97F}" type="presOf" srcId="{2DE3E10C-D72F-7B4C-AE2B-3FE8F124C95A}" destId="{A17083A3-4A5E-2D43-8A6F-6059B514B65D}" srcOrd="0" destOrd="0" presId="urn:microsoft.com/office/officeart/2005/8/layout/vList3"/>
+    <dgm:cxn modelId="{6A85E54F-58C6-4647-B919-C14FB80F1FF5}" srcId="{26A7AE75-0476-574B-AA09-6F2F478FD701}" destId="{568C78F9-C35A-A14E-9821-A3D78CFB2934}" srcOrd="3" destOrd="0" parTransId="{A63D79F8-F5B5-2C4F-A017-A9A65BD9DDDD}" sibTransId="{EAB264E4-6AD6-5D41-A46A-4AB73D1FCBB8}"/>
+    <dgm:cxn modelId="{B1F6E567-4D84-D045-8B88-9B8339374F78}" srcId="{26A7AE75-0476-574B-AA09-6F2F478FD701}" destId="{09DC5A73-DAD8-744A-BBEE-F90F6E5625BE}" srcOrd="6" destOrd="0" parTransId="{9F20319B-9D09-F541-A427-9D2B2B0ABB0F}" sibTransId="{98719CC5-A5AD-EE4D-A3F4-0847874471C7}"/>
+    <dgm:cxn modelId="{CA57CF6A-314A-1D46-9554-D53A98D7760E}" srcId="{26A7AE75-0476-574B-AA09-6F2F478FD701}" destId="{CA297D3B-B492-3940-8FCA-CBA149942607}" srcOrd="1" destOrd="0" parTransId="{3251D0AF-80B8-A047-B30C-EC5020A48052}" sibTransId="{8E6652C2-C9F4-0349-8223-BFB37697181E}"/>
+    <dgm:cxn modelId="{4DBE4483-8224-EB43-A6E6-C5FF3AFD21CE}" type="presOf" srcId="{09DC5A73-DAD8-744A-BBEE-F90F6E5625BE}" destId="{C414799E-A0D9-6C41-99BF-D5053E4B3D14}" srcOrd="0" destOrd="0" presId="urn:microsoft.com/office/officeart/2005/8/layout/vList3"/>
+    <dgm:cxn modelId="{FAD9D88F-FBF4-A74D-A12A-C50515C0B91C}" srcId="{26A7AE75-0476-574B-AA09-6F2F478FD701}" destId="{13B2C432-C4FC-D44C-8FF5-ED24902ADD08}" srcOrd="4" destOrd="0" parTransId="{769C505A-2566-3040-80B5-CE3FF5DB4EE3}" sibTransId="{DDAA1F0A-ECA1-C24E-A2C6-761C9D0861C8}"/>
+    <dgm:cxn modelId="{3BF809A1-5259-234F-96E4-9A1A67CE1BCA}" type="presOf" srcId="{568C78F9-C35A-A14E-9821-A3D78CFB2934}" destId="{B45F0CEB-30D1-F74B-834A-A5905852DEB6}" srcOrd="0" destOrd="0" presId="urn:microsoft.com/office/officeart/2005/8/layout/vList3"/>
+    <dgm:cxn modelId="{AF4584A4-700D-C84A-B04D-C4AA6DEF5E58}" type="presOf" srcId="{13B2C432-C4FC-D44C-8FF5-ED24902ADD08}" destId="{F7C2925B-D97D-F641-A653-47CAD8E1C38F}" srcOrd="0" destOrd="0" presId="urn:microsoft.com/office/officeart/2005/8/layout/vList3"/>
+    <dgm:cxn modelId="{677B30A5-EF60-2441-B4EB-CED46D865C6D}" type="presOf" srcId="{4753B252-6A65-5F4A-8734-5CBB42DC366E}" destId="{5D925EB2-B21E-724D-A7BD-31301F182B83}" srcOrd="0" destOrd="0" presId="urn:microsoft.com/office/officeart/2005/8/layout/vList3"/>
+    <dgm:cxn modelId="{64F761C0-E4FA-7D43-8F65-087CE1EFABE8}" srcId="{26A7AE75-0476-574B-AA09-6F2F478FD701}" destId="{2DE3E10C-D72F-7B4C-AE2B-3FE8F124C95A}" srcOrd="2" destOrd="0" parTransId="{784A0237-5093-3148-B872-372294A5D6F2}" sibTransId="{94FBFFAF-9DE0-154E-BFAB-6172F171FBFC}"/>
+    <dgm:cxn modelId="{E48857CC-210E-304C-B7B5-1FE9216230DD}" srcId="{26A7AE75-0476-574B-AA09-6F2F478FD701}" destId="{4753B252-6A65-5F4A-8734-5CBB42DC366E}" srcOrd="5" destOrd="0" parTransId="{DFD48EE3-EBB1-DC49-9DB3-7BDC79288494}" sibTransId="{F695F43A-8C5A-764A-A333-4A81E5C6721F}"/>
+    <dgm:cxn modelId="{E40714DB-1B98-A84D-B67F-DE31677FF39B}" type="presOf" srcId="{26A7AE75-0476-574B-AA09-6F2F478FD701}" destId="{1E14DD05-72DC-444B-9BEE-0593C9B5AB8C}" srcOrd="0" destOrd="0" presId="urn:microsoft.com/office/officeart/2005/8/layout/vList3"/>
+    <dgm:cxn modelId="{7DD9E359-25B9-134E-89DF-D39D1F93498D}" type="presParOf" srcId="{1E14DD05-72DC-444B-9BEE-0593C9B5AB8C}" destId="{BE3924EC-FCE2-1544-A1E7-55651C31AAD4}" srcOrd="0" destOrd="0" presId="urn:microsoft.com/office/officeart/2005/8/layout/vList3"/>
+    <dgm:cxn modelId="{6B7FA92E-A577-2D49-830C-CC253F3E1E5D}" type="presParOf" srcId="{BE3924EC-FCE2-1544-A1E7-55651C31AAD4}" destId="{3921451E-7F44-7148-8564-DD0161AD58D7}" srcOrd="0" destOrd="0" presId="urn:microsoft.com/office/officeart/2005/8/layout/vList3"/>
+    <dgm:cxn modelId="{E473B9DC-89DF-F14D-92B5-1C121FD9EC07}" type="presParOf" srcId="{BE3924EC-FCE2-1544-A1E7-55651C31AAD4}" destId="{67BCFC79-616B-4A47-83A6-5582B700891C}" srcOrd="1" destOrd="0" presId="urn:microsoft.com/office/officeart/2005/8/layout/vList3"/>
+    <dgm:cxn modelId="{038D348B-28A7-3643-A1C4-F76EEF46E9A1}" type="presParOf" srcId="{1E14DD05-72DC-444B-9BEE-0593C9B5AB8C}" destId="{D86CB79A-06EE-904F-BDCF-74BE76332FE8}" srcOrd="1" destOrd="0" presId="urn:microsoft.com/office/officeart/2005/8/layout/vList3"/>
+    <dgm:cxn modelId="{D9CB6C48-76FC-004E-9F26-7E0349547862}" type="presParOf" srcId="{1E14DD05-72DC-444B-9BEE-0593C9B5AB8C}" destId="{B707F65D-5A3B-9347-A5EC-D2B55FA47346}" srcOrd="2" destOrd="0" presId="urn:microsoft.com/office/officeart/2005/8/layout/vList3"/>
+    <dgm:cxn modelId="{923FD61F-DC54-B44F-90A1-39DAFEFEDCEC}" type="presParOf" srcId="{B707F65D-5A3B-9347-A5EC-D2B55FA47346}" destId="{5E287AE0-B3FA-0E44-BC11-C841BAE2CDD2}" srcOrd="0" destOrd="0" presId="urn:microsoft.com/office/officeart/2005/8/layout/vList3"/>
+    <dgm:cxn modelId="{A010F65F-E89C-4049-A0E4-6D28D4AAF1C6}" type="presParOf" srcId="{B707F65D-5A3B-9347-A5EC-D2B55FA47346}" destId="{F9462253-E1A8-734A-A481-5054139885B1}" srcOrd="1" destOrd="0" presId="urn:microsoft.com/office/officeart/2005/8/layout/vList3"/>
+    <dgm:cxn modelId="{B5E62F18-1365-A54C-9446-30E3390C6B5A}" type="presParOf" srcId="{1E14DD05-72DC-444B-9BEE-0593C9B5AB8C}" destId="{173D2260-5B6B-EC43-A5C0-4B4F815E7D1A}" srcOrd="3" destOrd="0" presId="urn:microsoft.com/office/officeart/2005/8/layout/vList3"/>
+    <dgm:cxn modelId="{B2B57F28-6D33-3648-A08B-0D376314EB5D}" type="presParOf" srcId="{1E14DD05-72DC-444B-9BEE-0593C9B5AB8C}" destId="{BD09F5A7-5FA7-1643-A1C9-F3176F458A6B}" srcOrd="4" destOrd="0" presId="urn:microsoft.com/office/officeart/2005/8/layout/vList3"/>
+    <dgm:cxn modelId="{CF0A24E1-6644-AA4D-A850-85BFBBC860E2}" type="presParOf" srcId="{BD09F5A7-5FA7-1643-A1C9-F3176F458A6B}" destId="{4C50786B-B7A0-7847-90D2-9E082AAFCF33}" srcOrd="0" destOrd="0" presId="urn:microsoft.com/office/officeart/2005/8/layout/vList3"/>
+    <dgm:cxn modelId="{CB8931DA-3C9F-F444-AC87-251D5625E425}" type="presParOf" srcId="{BD09F5A7-5FA7-1643-A1C9-F3176F458A6B}" destId="{A17083A3-4A5E-2D43-8A6F-6059B514B65D}" srcOrd="1" destOrd="0" presId="urn:microsoft.com/office/officeart/2005/8/layout/vList3"/>
+    <dgm:cxn modelId="{3AF2B446-9588-ED43-9546-82FD48D54000}" type="presParOf" srcId="{1E14DD05-72DC-444B-9BEE-0593C9B5AB8C}" destId="{5AAFC7F4-B3FD-AD47-8789-DBDD4FD3F7B8}" srcOrd="5" destOrd="0" presId="urn:microsoft.com/office/officeart/2005/8/layout/vList3"/>
+    <dgm:cxn modelId="{E619BED2-9300-A444-A46C-37B28F2145E6}" type="presParOf" srcId="{1E14DD05-72DC-444B-9BEE-0593C9B5AB8C}" destId="{821EA1C5-A0B2-7D41-AC4D-BB8262AE5A56}" srcOrd="6" destOrd="0" presId="urn:microsoft.com/office/officeart/2005/8/layout/vList3"/>
+    <dgm:cxn modelId="{277301B2-EF71-2448-8326-1232080E4917}" type="presParOf" srcId="{821EA1C5-A0B2-7D41-AC4D-BB8262AE5A56}" destId="{1329C8F6-9AB5-6E42-8B22-1D9F87A0AD93}" srcOrd="0" destOrd="0" presId="urn:microsoft.com/office/officeart/2005/8/layout/vList3"/>
+    <dgm:cxn modelId="{42EE05FC-6F26-7E4C-9A64-300498B34C12}" type="presParOf" srcId="{821EA1C5-A0B2-7D41-AC4D-BB8262AE5A56}" destId="{B45F0CEB-30D1-F74B-834A-A5905852DEB6}" srcOrd="1" destOrd="0" presId="urn:microsoft.com/office/officeart/2005/8/layout/vList3"/>
+    <dgm:cxn modelId="{CBB302CE-2FED-8A42-B46C-886A128CB1BB}" type="presParOf" srcId="{1E14DD05-72DC-444B-9BEE-0593C9B5AB8C}" destId="{538EBA98-9637-DC4D-9362-6B88A1997EA3}" srcOrd="7" destOrd="0" presId="urn:microsoft.com/office/officeart/2005/8/layout/vList3"/>
+    <dgm:cxn modelId="{D235A7FE-575B-4A4A-8372-803A35D3D60C}" type="presParOf" srcId="{1E14DD05-72DC-444B-9BEE-0593C9B5AB8C}" destId="{015FE6EF-7894-4E4D-87C9-1D78F8487627}" srcOrd="8" destOrd="0" presId="urn:microsoft.com/office/officeart/2005/8/layout/vList3"/>
+    <dgm:cxn modelId="{3303B5E4-505F-9946-95E9-ED11BD6E53ED}" type="presParOf" srcId="{015FE6EF-7894-4E4D-87C9-1D78F8487627}" destId="{68174192-DC14-B44E-8134-DC8F2915521D}" srcOrd="0" destOrd="0" presId="urn:microsoft.com/office/officeart/2005/8/layout/vList3"/>
+    <dgm:cxn modelId="{348FA925-BA49-7047-978E-A953ABB39156}" type="presParOf" srcId="{015FE6EF-7894-4E4D-87C9-1D78F8487627}" destId="{F7C2925B-D97D-F641-A653-47CAD8E1C38F}" srcOrd="1" destOrd="0" presId="urn:microsoft.com/office/officeart/2005/8/layout/vList3"/>
+    <dgm:cxn modelId="{987DD400-F356-3340-BB87-5C39A3464C5E}" type="presParOf" srcId="{1E14DD05-72DC-444B-9BEE-0593C9B5AB8C}" destId="{1460DDEB-70D3-934B-B8C7-0A60BFBF2D7A}" srcOrd="9" destOrd="0" presId="urn:microsoft.com/office/officeart/2005/8/layout/vList3"/>
+    <dgm:cxn modelId="{22A1CFE2-2BBB-A545-91EE-93E7B4273DCB}" type="presParOf" srcId="{1E14DD05-72DC-444B-9BEE-0593C9B5AB8C}" destId="{C594405A-C05D-3740-9D3D-445388FAD988}" srcOrd="10" destOrd="0" presId="urn:microsoft.com/office/officeart/2005/8/layout/vList3"/>
+    <dgm:cxn modelId="{064A2812-7E5B-4648-9A87-C1A5510F1C10}" type="presParOf" srcId="{C594405A-C05D-3740-9D3D-445388FAD988}" destId="{92394F4F-528D-384C-B61D-61490A740255}" srcOrd="0" destOrd="0" presId="urn:microsoft.com/office/officeart/2005/8/layout/vList3"/>
+    <dgm:cxn modelId="{DD370C4B-A38D-234E-88A2-8290472330BB}" type="presParOf" srcId="{C594405A-C05D-3740-9D3D-445388FAD988}" destId="{5D925EB2-B21E-724D-A7BD-31301F182B83}" srcOrd="1" destOrd="0" presId="urn:microsoft.com/office/officeart/2005/8/layout/vList3"/>
+    <dgm:cxn modelId="{748DA80B-20B1-234D-8BCE-D65858DA3C40}" type="presParOf" srcId="{1E14DD05-72DC-444B-9BEE-0593C9B5AB8C}" destId="{C981361A-2C19-9C49-985B-50CC11175B16}" srcOrd="11" destOrd="0" presId="urn:microsoft.com/office/officeart/2005/8/layout/vList3"/>
+    <dgm:cxn modelId="{D09DC484-F3A5-7C44-A1D6-9F99E14895FE}" type="presParOf" srcId="{1E14DD05-72DC-444B-9BEE-0593C9B5AB8C}" destId="{B125B05E-6F6C-244B-B801-BBDBF1FD9F4E}" srcOrd="12" destOrd="0" presId="urn:microsoft.com/office/officeart/2005/8/layout/vList3"/>
+    <dgm:cxn modelId="{B3B8F130-2773-6249-B20D-D837AB340577}" type="presParOf" srcId="{B125B05E-6F6C-244B-B801-BBDBF1FD9F4E}" destId="{3B5A8344-2F5A-DE49-97B1-00D7C60CFA26}" srcOrd="0" destOrd="0" presId="urn:microsoft.com/office/officeart/2005/8/layout/vList3"/>
+    <dgm:cxn modelId="{C873DC97-0E6D-BA45-BB65-05DED3E1FC34}" type="presParOf" srcId="{B125B05E-6F6C-244B-B801-BBDBF1FD9F4E}" destId="{C414799E-A0D9-6C41-99BF-D5053E4B3D14}" srcOrd="1" destOrd="0" presId="urn:microsoft.com/office/officeart/2005/8/layout/vList3"/>
+  </dgm:cxnLst>
+  <dgm:bg/>
+  <dgm:whole/>
+  <dgm:extLst>
+    <a:ext uri="http://schemas.microsoft.com/office/drawing/2008/diagram">
+      <dsp:dataModelExt xmlns:dsp="http://schemas.microsoft.com/office/drawing/2008/diagram" relId="rId6" minVer="http://schemas.openxmlformats.org/drawingml/2006/diagram"/>
+    </a:ext>
+  </dgm:extLst>
+</dgm:dataModel>
+</file>
+
+<file path=ppt/diagrams/drawing1.xml><?xml version="1.0" encoding="utf-8"?>
+<dsp:drawing xmlns:dgm="http://schemas.openxmlformats.org/drawingml/2006/diagram" xmlns:dsp="http://schemas.microsoft.com/office/drawing/2008/diagram" xmlns:a="http://schemas.openxmlformats.org/drawingml/2006/main">
+  <dsp:spTree>
+    <dsp:nvGrpSpPr>
+      <dsp:cNvPr id="0" name=""/>
+      <dsp:cNvGrpSpPr/>
+    </dsp:nvGrpSpPr>
+    <dsp:grpSpPr/>
+    <dsp:sp modelId="{67BCFC79-616B-4A47-83A6-5582B700891C}">
+      <dsp:nvSpPr>
+        <dsp:cNvPr id="0" name=""/>
+        <dsp:cNvSpPr/>
+      </dsp:nvSpPr>
+      <dsp:spPr>
+        <a:xfrm rot="10800000">
+          <a:off x="-1" y="370"/>
+          <a:ext cx="7944547" cy="409349"/>
+        </a:xfrm>
+        <a:prstGeom prst="homePlate">
+          <a:avLst/>
+        </a:prstGeom>
+        <a:solidFill>
+          <a:srgbClr val="46A01E"/>
+        </a:solidFill>
+        <a:ln w="25400" cap="flat" cmpd="sng" algn="ctr">
+          <a:solidFill>
+            <a:schemeClr val="lt1">
+              <a:hueOff val="0"/>
+              <a:satOff val="0"/>
+              <a:lumOff val="0"/>
+              <a:alphaOff val="0"/>
+            </a:schemeClr>
+          </a:solidFill>
+          <a:prstDash val="solid"/>
+        </a:ln>
+        <a:effectLst/>
+      </dsp:spPr>
+      <dsp:style>
+        <a:lnRef idx="2">
+          <a:scrgbClr r="0" g="0" b="0"/>
+        </a:lnRef>
+        <a:fillRef idx="1">
+          <a:scrgbClr r="0" g="0" b="0"/>
+        </a:fillRef>
+        <a:effectRef idx="0">
+          <a:scrgbClr r="0" g="0" b="0"/>
+        </a:effectRef>
+        <a:fontRef idx="minor">
+          <a:schemeClr val="lt1"/>
+        </a:fontRef>
+      </dsp:style>
+      <dsp:txBody>
+        <a:bodyPr spcFirstLastPara="0" vert="horz" wrap="square" lIns="180512" tIns="72390" rIns="135128" bIns="72390" numCol="1" spcCol="1270" anchor="ctr" anchorCtr="0">
+          <a:noAutofit/>
+        </a:bodyPr>
+        <a:lstStyle/>
+        <a:p>
+          <a:pPr marL="0" lvl="0" indent="0" algn="ctr" defTabSz="844550">
+            <a:lnSpc>
+              <a:spcPct val="90000"/>
+            </a:lnSpc>
+            <a:spcBef>
+              <a:spcPct val="0"/>
+            </a:spcBef>
+            <a:spcAft>
+              <a:spcPct val="35000"/>
+            </a:spcAft>
+            <a:buNone/>
+          </a:pPr>
+          <a:r>
+            <a:rPr lang="en-GB" sz="1900" kern="1200" dirty="0" err="1"/>
+            <a:t>Contesto</a:t>
+          </a:r>
+          <a:r>
+            <a:rPr lang="en-GB" sz="1900" kern="1200" dirty="0"/>
+            <a:t> e </a:t>
+          </a:r>
+          <a:r>
+            <a:rPr lang="en-GB" sz="1900" kern="1200" dirty="0" err="1"/>
+            <a:t>Motivazione</a:t>
+          </a:r>
+          <a:endParaRPr lang="en-GB" sz="1900" kern="1200" dirty="0"/>
+        </a:p>
+      </dsp:txBody>
+      <dsp:txXfrm rot="10800000">
+        <a:off x="102336" y="370"/>
+        <a:ext cx="7842210" cy="409349"/>
+      </dsp:txXfrm>
+    </dsp:sp>
+    <dsp:sp modelId="{3921451E-7F44-7148-8564-DD0161AD58D7}">
+      <dsp:nvSpPr>
+        <dsp:cNvPr id="0" name=""/>
+        <dsp:cNvSpPr/>
+      </dsp:nvSpPr>
+      <dsp:spPr>
+        <a:xfrm>
+          <a:off x="1" y="2"/>
+          <a:ext cx="409349" cy="409349"/>
+        </a:xfrm>
+        <a:prstGeom prst="ellipse">
+          <a:avLst/>
+        </a:prstGeom>
+        <a:solidFill>
+          <a:schemeClr val="accent6">
+            <a:lumMod val="20000"/>
+            <a:lumOff val="80000"/>
+          </a:schemeClr>
+        </a:solidFill>
+        <a:ln w="25400" cap="flat" cmpd="sng" algn="ctr">
+          <a:solidFill>
+            <a:schemeClr val="lt1">
+              <a:hueOff val="0"/>
+              <a:satOff val="0"/>
+              <a:lumOff val="0"/>
+              <a:alphaOff val="0"/>
+            </a:schemeClr>
+          </a:solidFill>
+          <a:prstDash val="solid"/>
+        </a:ln>
+        <a:effectLst/>
+      </dsp:spPr>
+      <dsp:style>
+        <a:lnRef idx="2">
+          <a:scrgbClr r="0" g="0" b="0"/>
+        </a:lnRef>
+        <a:fillRef idx="1">
+          <a:scrgbClr r="0" g="0" b="0"/>
+        </a:fillRef>
+        <a:effectRef idx="0">
+          <a:scrgbClr r="0" g="0" b="0"/>
+        </a:effectRef>
+        <a:fontRef idx="minor"/>
+      </dsp:style>
+    </dsp:sp>
+    <dsp:sp modelId="{F9462253-E1A8-734A-A481-5054139885B1}">
+      <dsp:nvSpPr>
+        <dsp:cNvPr id="0" name=""/>
+        <dsp:cNvSpPr/>
+      </dsp:nvSpPr>
+      <dsp:spPr>
+        <a:xfrm rot="10800000">
+          <a:off x="-1" y="531914"/>
+          <a:ext cx="7944547" cy="410397"/>
+        </a:xfrm>
+        <a:prstGeom prst="homePlate">
+          <a:avLst/>
+        </a:prstGeom>
+        <a:solidFill>
+          <a:srgbClr val="58A322"/>
+        </a:solidFill>
+        <a:ln w="25400" cap="flat" cmpd="sng" algn="ctr">
+          <a:solidFill>
+            <a:schemeClr val="lt1">
+              <a:hueOff val="0"/>
+              <a:satOff val="0"/>
+              <a:lumOff val="0"/>
+              <a:alphaOff val="0"/>
+            </a:schemeClr>
+          </a:solidFill>
+          <a:prstDash val="solid"/>
+        </a:ln>
+        <a:effectLst/>
+      </dsp:spPr>
+      <dsp:style>
+        <a:lnRef idx="2">
+          <a:scrgbClr r="0" g="0" b="0"/>
+        </a:lnRef>
+        <a:fillRef idx="1">
+          <a:scrgbClr r="0" g="0" b="0"/>
+        </a:fillRef>
+        <a:effectRef idx="0">
+          <a:scrgbClr r="0" g="0" b="0"/>
+        </a:effectRef>
+        <a:fontRef idx="minor">
+          <a:schemeClr val="lt1"/>
+        </a:fontRef>
+      </dsp:style>
+      <dsp:txBody>
+        <a:bodyPr spcFirstLastPara="0" vert="horz" wrap="square" lIns="180512" tIns="72390" rIns="135128" bIns="72390" numCol="1" spcCol="1270" anchor="ctr" anchorCtr="0">
+          <a:noAutofit/>
+        </a:bodyPr>
+        <a:lstStyle/>
+        <a:p>
+          <a:pPr marL="0" lvl="0" indent="0" algn="ctr" defTabSz="844550">
+            <a:lnSpc>
+              <a:spcPct val="90000"/>
+            </a:lnSpc>
+            <a:spcBef>
+              <a:spcPct val="0"/>
+            </a:spcBef>
+            <a:spcAft>
+              <a:spcPct val="35000"/>
+            </a:spcAft>
+            <a:buNone/>
+          </a:pPr>
+          <a:r>
+            <a:rPr lang="en-GB" sz="1900" kern="1200" dirty="0" err="1"/>
+            <a:t>Obbiettivo</a:t>
+          </a:r>
+          <a:endParaRPr lang="en-GB" sz="1900" kern="1200" dirty="0"/>
+        </a:p>
+      </dsp:txBody>
+      <dsp:txXfrm rot="10800000">
+        <a:off x="102598" y="531914"/>
+        <a:ext cx="7841948" cy="410397"/>
+      </dsp:txXfrm>
+    </dsp:sp>
+    <dsp:sp modelId="{5E287AE0-B3FA-0E44-BC11-C841BAE2CDD2}">
+      <dsp:nvSpPr>
+        <dsp:cNvPr id="0" name=""/>
+        <dsp:cNvSpPr/>
+      </dsp:nvSpPr>
+      <dsp:spPr>
+        <a:xfrm>
+          <a:off x="0" y="532814"/>
+          <a:ext cx="409349" cy="409349"/>
+        </a:xfrm>
+        <a:prstGeom prst="ellipse">
+          <a:avLst/>
+        </a:prstGeom>
+        <a:solidFill>
+          <a:schemeClr val="accent6">
+            <a:lumMod val="20000"/>
+            <a:lumOff val="80000"/>
+          </a:schemeClr>
+        </a:solidFill>
+        <a:ln w="25400" cap="flat" cmpd="sng" algn="ctr">
+          <a:solidFill>
+            <a:schemeClr val="lt1">
+              <a:hueOff val="0"/>
+              <a:satOff val="0"/>
+              <a:lumOff val="0"/>
+              <a:alphaOff val="0"/>
+            </a:schemeClr>
+          </a:solidFill>
+          <a:prstDash val="solid"/>
+        </a:ln>
+        <a:effectLst/>
+      </dsp:spPr>
+      <dsp:style>
+        <a:lnRef idx="2">
+          <a:scrgbClr r="0" g="0" b="0"/>
+        </a:lnRef>
+        <a:fillRef idx="1">
+          <a:scrgbClr r="0" g="0" b="0"/>
+        </a:fillRef>
+        <a:effectRef idx="0">
+          <a:scrgbClr r="0" g="0" b="0"/>
+        </a:effectRef>
+        <a:fontRef idx="minor"/>
+      </dsp:style>
+    </dsp:sp>
+    <dsp:sp modelId="{A17083A3-4A5E-2D43-8A6F-6059B514B65D}">
+      <dsp:nvSpPr>
+        <dsp:cNvPr id="0" name=""/>
+        <dsp:cNvSpPr/>
+      </dsp:nvSpPr>
+      <dsp:spPr>
+        <a:xfrm rot="10800000">
+          <a:off x="-1" y="1064505"/>
+          <a:ext cx="7944547" cy="409349"/>
+        </a:xfrm>
+        <a:prstGeom prst="homePlate">
+          <a:avLst/>
+        </a:prstGeom>
+        <a:solidFill>
+          <a:srgbClr val="61A424"/>
+        </a:solidFill>
+        <a:ln w="25400" cap="flat" cmpd="sng" algn="ctr">
+          <a:solidFill>
+            <a:schemeClr val="lt1">
+              <a:hueOff val="0"/>
+              <a:satOff val="0"/>
+              <a:lumOff val="0"/>
+              <a:alphaOff val="0"/>
+            </a:schemeClr>
+          </a:solidFill>
+          <a:prstDash val="solid"/>
+        </a:ln>
+        <a:effectLst/>
+      </dsp:spPr>
+      <dsp:style>
+        <a:lnRef idx="2">
+          <a:scrgbClr r="0" g="0" b="0"/>
+        </a:lnRef>
+        <a:fillRef idx="1">
+          <a:scrgbClr r="0" g="0" b="0"/>
+        </a:fillRef>
+        <a:effectRef idx="0">
+          <a:scrgbClr r="0" g="0" b="0"/>
+        </a:effectRef>
+        <a:fontRef idx="minor">
+          <a:schemeClr val="lt1"/>
+        </a:fontRef>
+      </dsp:style>
+      <dsp:txBody>
+        <a:bodyPr spcFirstLastPara="0" vert="horz" wrap="square" lIns="180512" tIns="72390" rIns="135128" bIns="72390" numCol="1" spcCol="1270" anchor="ctr" anchorCtr="0">
+          <a:noAutofit/>
+        </a:bodyPr>
+        <a:lstStyle/>
+        <a:p>
+          <a:pPr marL="0" lvl="0" indent="0" algn="ctr" defTabSz="844550">
+            <a:lnSpc>
+              <a:spcPct val="90000"/>
+            </a:lnSpc>
+            <a:spcBef>
+              <a:spcPct val="0"/>
+            </a:spcBef>
+            <a:spcAft>
+              <a:spcPct val="35000"/>
+            </a:spcAft>
+            <a:buNone/>
+          </a:pPr>
+          <a:r>
+            <a:rPr lang="en-GB" sz="1900" kern="1200" dirty="0" err="1"/>
+            <a:t>Problemi</a:t>
+          </a:r>
+          <a:endParaRPr lang="en-GB" sz="1900" kern="1200" dirty="0"/>
+        </a:p>
+      </dsp:txBody>
+      <dsp:txXfrm rot="10800000">
+        <a:off x="102336" y="1064505"/>
+        <a:ext cx="7842210" cy="409349"/>
+      </dsp:txXfrm>
+    </dsp:sp>
+    <dsp:sp modelId="{4C50786B-B7A0-7847-90D2-9E082AAFCF33}">
+      <dsp:nvSpPr>
+        <dsp:cNvPr id="0" name=""/>
+        <dsp:cNvSpPr/>
+      </dsp:nvSpPr>
+      <dsp:spPr>
+        <a:xfrm>
+          <a:off x="0" y="1064882"/>
+          <a:ext cx="409349" cy="409349"/>
+        </a:xfrm>
+        <a:prstGeom prst="ellipse">
+          <a:avLst/>
+        </a:prstGeom>
+        <a:solidFill>
+          <a:schemeClr val="accent6">
+            <a:lumMod val="20000"/>
+            <a:lumOff val="80000"/>
+          </a:schemeClr>
+        </a:solidFill>
+        <a:ln w="25400" cap="flat" cmpd="sng" algn="ctr">
+          <a:solidFill>
+            <a:schemeClr val="lt1">
+              <a:hueOff val="0"/>
+              <a:satOff val="0"/>
+              <a:lumOff val="0"/>
+              <a:alphaOff val="0"/>
+            </a:schemeClr>
+          </a:solidFill>
+          <a:prstDash val="solid"/>
+        </a:ln>
+        <a:effectLst/>
+      </dsp:spPr>
+      <dsp:style>
+        <a:lnRef idx="2">
+          <a:scrgbClr r="0" g="0" b="0"/>
+        </a:lnRef>
+        <a:fillRef idx="1">
+          <a:scrgbClr r="0" g="0" b="0"/>
+        </a:fillRef>
+        <a:effectRef idx="0">
+          <a:scrgbClr r="0" g="0" b="0"/>
+        </a:effectRef>
+        <a:fontRef idx="minor"/>
+      </dsp:style>
+    </dsp:sp>
+    <dsp:sp modelId="{B45F0CEB-30D1-F74B-834A-A5905852DEB6}">
+      <dsp:nvSpPr>
+        <dsp:cNvPr id="0" name=""/>
+        <dsp:cNvSpPr/>
+      </dsp:nvSpPr>
+      <dsp:spPr>
+        <a:xfrm rot="10800000">
+          <a:off x="-1" y="1596049"/>
+          <a:ext cx="7944547" cy="409349"/>
+        </a:xfrm>
+        <a:prstGeom prst="homePlate">
+          <a:avLst/>
+        </a:prstGeom>
+        <a:solidFill>
+          <a:srgbClr val="6AA525"/>
+        </a:solidFill>
+        <a:ln w="25400" cap="flat" cmpd="sng" algn="ctr">
+          <a:solidFill>
+            <a:schemeClr val="lt1">
+              <a:hueOff val="0"/>
+              <a:satOff val="0"/>
+              <a:lumOff val="0"/>
+              <a:alphaOff val="0"/>
+            </a:schemeClr>
+          </a:solidFill>
+          <a:prstDash val="solid"/>
+        </a:ln>
+        <a:effectLst/>
+      </dsp:spPr>
+      <dsp:style>
+        <a:lnRef idx="2">
+          <a:scrgbClr r="0" g="0" b="0"/>
+        </a:lnRef>
+        <a:fillRef idx="1">
+          <a:scrgbClr r="0" g="0" b="0"/>
+        </a:fillRef>
+        <a:effectRef idx="0">
+          <a:scrgbClr r="0" g="0" b="0"/>
+        </a:effectRef>
+        <a:fontRef idx="minor">
+          <a:schemeClr val="lt1"/>
+        </a:fontRef>
+      </dsp:style>
+      <dsp:txBody>
+        <a:bodyPr spcFirstLastPara="0" vert="horz" wrap="square" lIns="180512" tIns="72390" rIns="135128" bIns="72390" numCol="1" spcCol="1270" anchor="ctr" anchorCtr="0">
+          <a:noAutofit/>
+        </a:bodyPr>
+        <a:lstStyle/>
+        <a:p>
+          <a:pPr marL="0" lvl="0" indent="0" algn="ctr" defTabSz="844550">
+            <a:lnSpc>
+              <a:spcPct val="90000"/>
+            </a:lnSpc>
+            <a:spcBef>
+              <a:spcPct val="0"/>
+            </a:spcBef>
+            <a:spcAft>
+              <a:spcPct val="35000"/>
+            </a:spcAft>
+            <a:buNone/>
+          </a:pPr>
+          <a:r>
+            <a:rPr lang="en-GB" sz="1900" kern="1200" dirty="0"/>
+            <a:t>Stato dell’arte</a:t>
+          </a:r>
+        </a:p>
+      </dsp:txBody>
+      <dsp:txXfrm rot="10800000">
+        <a:off x="102336" y="1596049"/>
+        <a:ext cx="7842210" cy="409349"/>
+      </dsp:txXfrm>
+    </dsp:sp>
+    <dsp:sp modelId="{1329C8F6-9AB5-6E42-8B22-1D9F87A0AD93}">
+      <dsp:nvSpPr>
+        <dsp:cNvPr id="0" name=""/>
+        <dsp:cNvSpPr/>
+      </dsp:nvSpPr>
+      <dsp:spPr>
+        <a:xfrm>
+          <a:off x="0" y="1596425"/>
+          <a:ext cx="409349" cy="409349"/>
+        </a:xfrm>
+        <a:prstGeom prst="ellipse">
+          <a:avLst/>
+        </a:prstGeom>
+        <a:solidFill>
+          <a:schemeClr val="accent6">
+            <a:lumMod val="20000"/>
+            <a:lumOff val="80000"/>
+          </a:schemeClr>
+        </a:solidFill>
+        <a:ln w="25400" cap="flat" cmpd="sng" algn="ctr">
+          <a:solidFill>
+            <a:schemeClr val="lt1">
+              <a:hueOff val="0"/>
+              <a:satOff val="0"/>
+              <a:lumOff val="0"/>
+              <a:alphaOff val="0"/>
+            </a:schemeClr>
+          </a:solidFill>
+          <a:prstDash val="solid"/>
+        </a:ln>
+        <a:effectLst/>
+      </dsp:spPr>
+      <dsp:style>
+        <a:lnRef idx="2">
+          <a:scrgbClr r="0" g="0" b="0"/>
+        </a:lnRef>
+        <a:fillRef idx="1">
+          <a:scrgbClr r="0" g="0" b="0"/>
+        </a:fillRef>
+        <a:effectRef idx="0">
+          <a:scrgbClr r="0" g="0" b="0"/>
+        </a:effectRef>
+        <a:fontRef idx="minor"/>
+      </dsp:style>
+    </dsp:sp>
+    <dsp:sp modelId="{F7C2925B-D97D-F641-A653-47CAD8E1C38F}">
+      <dsp:nvSpPr>
+        <dsp:cNvPr id="0" name=""/>
+        <dsp:cNvSpPr/>
+      </dsp:nvSpPr>
+      <dsp:spPr>
+        <a:xfrm rot="10800000">
+          <a:off x="-1" y="2127592"/>
+          <a:ext cx="7944547" cy="409349"/>
+        </a:xfrm>
+        <a:prstGeom prst="homePlate">
+          <a:avLst/>
+        </a:prstGeom>
+        <a:solidFill>
+          <a:srgbClr val="73B12B"/>
+        </a:solidFill>
+        <a:ln w="25400" cap="flat" cmpd="sng" algn="ctr">
+          <a:solidFill>
+            <a:schemeClr val="lt1">
+              <a:hueOff val="0"/>
+              <a:satOff val="0"/>
+              <a:lumOff val="0"/>
+              <a:alphaOff val="0"/>
+            </a:schemeClr>
+          </a:solidFill>
+          <a:prstDash val="solid"/>
+        </a:ln>
+        <a:effectLst/>
+      </dsp:spPr>
+      <dsp:style>
+        <a:lnRef idx="2">
+          <a:scrgbClr r="0" g="0" b="0"/>
+        </a:lnRef>
+        <a:fillRef idx="1">
+          <a:scrgbClr r="0" g="0" b="0"/>
+        </a:fillRef>
+        <a:effectRef idx="0">
+          <a:scrgbClr r="0" g="0" b="0"/>
+        </a:effectRef>
+        <a:fontRef idx="minor">
+          <a:schemeClr val="lt1"/>
+        </a:fontRef>
+      </dsp:style>
+      <dsp:txBody>
+        <a:bodyPr spcFirstLastPara="0" vert="horz" wrap="square" lIns="180512" tIns="72390" rIns="135128" bIns="72390" numCol="1" spcCol="1270" anchor="ctr" anchorCtr="0">
+          <a:noAutofit/>
+        </a:bodyPr>
+        <a:lstStyle/>
+        <a:p>
+          <a:pPr marL="0" lvl="0" indent="0" algn="ctr" defTabSz="844550">
+            <a:lnSpc>
+              <a:spcPct val="90000"/>
+            </a:lnSpc>
+            <a:spcBef>
+              <a:spcPct val="0"/>
+            </a:spcBef>
+            <a:spcAft>
+              <a:spcPct val="35000"/>
+            </a:spcAft>
+            <a:buNone/>
+          </a:pPr>
+          <a:r>
+            <a:rPr lang="en-GB" sz="1900" kern="1200" dirty="0" err="1"/>
+            <a:t>Approccio</a:t>
+          </a:r>
+          <a:endParaRPr lang="en-GB" sz="1900" kern="1200" dirty="0"/>
+        </a:p>
+      </dsp:txBody>
+      <dsp:txXfrm rot="10800000">
+        <a:off x="102336" y="2127592"/>
+        <a:ext cx="7842210" cy="409349"/>
+      </dsp:txXfrm>
+    </dsp:sp>
+    <dsp:sp modelId="{68174192-DC14-B44E-8134-DC8F2915521D}">
+      <dsp:nvSpPr>
+        <dsp:cNvPr id="0" name=""/>
+        <dsp:cNvSpPr/>
+      </dsp:nvSpPr>
+      <dsp:spPr>
+        <a:xfrm>
+          <a:off x="0" y="2127969"/>
+          <a:ext cx="409349" cy="409349"/>
+        </a:xfrm>
+        <a:prstGeom prst="ellipse">
+          <a:avLst/>
+        </a:prstGeom>
+        <a:solidFill>
+          <a:schemeClr val="accent6">
+            <a:lumMod val="20000"/>
+            <a:lumOff val="80000"/>
+          </a:schemeClr>
+        </a:solidFill>
+        <a:ln w="25400" cap="flat" cmpd="sng" algn="ctr">
+          <a:solidFill>
+            <a:schemeClr val="lt1">
+              <a:hueOff val="0"/>
+              <a:satOff val="0"/>
+              <a:lumOff val="0"/>
+              <a:alphaOff val="0"/>
+            </a:schemeClr>
+          </a:solidFill>
+          <a:prstDash val="solid"/>
+        </a:ln>
+        <a:effectLst/>
+      </dsp:spPr>
+      <dsp:style>
+        <a:lnRef idx="2">
+          <a:scrgbClr r="0" g="0" b="0"/>
+        </a:lnRef>
+        <a:fillRef idx="1">
+          <a:scrgbClr r="0" g="0" b="0"/>
+        </a:fillRef>
+        <a:effectRef idx="0">
+          <a:scrgbClr r="0" g="0" b="0"/>
+        </a:effectRef>
+        <a:fontRef idx="minor"/>
+      </dsp:style>
+    </dsp:sp>
+    <dsp:sp modelId="{5D925EB2-B21E-724D-A7BD-31301F182B83}">
+      <dsp:nvSpPr>
+        <dsp:cNvPr id="0" name=""/>
+        <dsp:cNvSpPr/>
+      </dsp:nvSpPr>
+      <dsp:spPr>
+        <a:xfrm rot="10800000">
+          <a:off x="-1" y="2659136"/>
+          <a:ext cx="7944547" cy="409349"/>
+        </a:xfrm>
+        <a:prstGeom prst="homePlate">
+          <a:avLst/>
+        </a:prstGeom>
+        <a:solidFill>
+          <a:srgbClr val="7BBC31"/>
+        </a:solidFill>
+        <a:ln w="25400" cap="flat" cmpd="sng" algn="ctr">
+          <a:solidFill>
+            <a:schemeClr val="lt1">
+              <a:hueOff val="0"/>
+              <a:satOff val="0"/>
+              <a:lumOff val="0"/>
+              <a:alphaOff val="0"/>
+            </a:schemeClr>
+          </a:solidFill>
+          <a:prstDash val="solid"/>
+        </a:ln>
+        <a:effectLst/>
+      </dsp:spPr>
+      <dsp:style>
+        <a:lnRef idx="2">
+          <a:scrgbClr r="0" g="0" b="0"/>
+        </a:lnRef>
+        <a:fillRef idx="1">
+          <a:scrgbClr r="0" g="0" b="0"/>
+        </a:fillRef>
+        <a:effectRef idx="0">
+          <a:scrgbClr r="0" g="0" b="0"/>
+        </a:effectRef>
+        <a:fontRef idx="minor">
+          <a:schemeClr val="lt1"/>
+        </a:fontRef>
+      </dsp:style>
+      <dsp:txBody>
+        <a:bodyPr spcFirstLastPara="0" vert="horz" wrap="square" lIns="180512" tIns="72390" rIns="135128" bIns="72390" numCol="1" spcCol="1270" anchor="ctr" anchorCtr="0">
+          <a:noAutofit/>
+        </a:bodyPr>
+        <a:lstStyle/>
+        <a:p>
+          <a:pPr marL="0" lvl="0" indent="0" algn="ctr" defTabSz="844550">
+            <a:lnSpc>
+              <a:spcPct val="90000"/>
+            </a:lnSpc>
+            <a:spcBef>
+              <a:spcPct val="0"/>
+            </a:spcBef>
+            <a:spcAft>
+              <a:spcPct val="35000"/>
+            </a:spcAft>
+            <a:buNone/>
+          </a:pPr>
+          <a:r>
+            <a:rPr lang="en-GB" sz="1900" kern="1200" dirty="0" err="1"/>
+            <a:t>Risultato</a:t>
+          </a:r>
+          <a:endParaRPr lang="en-GB" sz="1900" kern="1200" dirty="0"/>
+        </a:p>
+      </dsp:txBody>
+      <dsp:txXfrm rot="10800000">
+        <a:off x="102336" y="2659136"/>
+        <a:ext cx="7842210" cy="409349"/>
+      </dsp:txXfrm>
+    </dsp:sp>
+    <dsp:sp modelId="{92394F4F-528D-384C-B61D-61490A740255}">
+      <dsp:nvSpPr>
+        <dsp:cNvPr id="0" name=""/>
+        <dsp:cNvSpPr/>
+      </dsp:nvSpPr>
+      <dsp:spPr>
+        <a:xfrm>
+          <a:off x="0" y="2659512"/>
+          <a:ext cx="409349" cy="409349"/>
+        </a:xfrm>
+        <a:prstGeom prst="ellipse">
+          <a:avLst/>
+        </a:prstGeom>
+        <a:solidFill>
+          <a:schemeClr val="accent6">
+            <a:lumMod val="20000"/>
+            <a:lumOff val="80000"/>
+          </a:schemeClr>
+        </a:solidFill>
+        <a:ln w="25400" cap="flat" cmpd="sng" algn="ctr">
+          <a:solidFill>
+            <a:schemeClr val="lt1">
+              <a:hueOff val="0"/>
+              <a:satOff val="0"/>
+              <a:lumOff val="0"/>
+              <a:alphaOff val="0"/>
+            </a:schemeClr>
+          </a:solidFill>
+          <a:prstDash val="solid"/>
+        </a:ln>
+        <a:effectLst/>
+      </dsp:spPr>
+      <dsp:style>
+        <a:lnRef idx="2">
+          <a:scrgbClr r="0" g="0" b="0"/>
+        </a:lnRef>
+        <a:fillRef idx="1">
+          <a:scrgbClr r="0" g="0" b="0"/>
+        </a:fillRef>
+        <a:effectRef idx="0">
+          <a:scrgbClr r="0" g="0" b="0"/>
+        </a:effectRef>
+        <a:fontRef idx="minor"/>
+      </dsp:style>
+    </dsp:sp>
+    <dsp:sp modelId="{C414799E-A0D9-6C41-99BF-D5053E4B3D14}">
+      <dsp:nvSpPr>
+        <dsp:cNvPr id="0" name=""/>
+        <dsp:cNvSpPr/>
+      </dsp:nvSpPr>
+      <dsp:spPr>
+        <a:xfrm rot="10800000">
+          <a:off x="-1" y="3190679"/>
+          <a:ext cx="7944547" cy="409349"/>
+        </a:xfrm>
+        <a:prstGeom prst="homePlate">
+          <a:avLst/>
+        </a:prstGeom>
+        <a:solidFill>
+          <a:schemeClr val="accent6"/>
+        </a:solidFill>
+        <a:ln w="25400" cap="flat" cmpd="sng" algn="ctr">
+          <a:solidFill>
+            <a:schemeClr val="lt1">
+              <a:hueOff val="0"/>
+              <a:satOff val="0"/>
+              <a:lumOff val="0"/>
+              <a:alphaOff val="0"/>
+            </a:schemeClr>
+          </a:solidFill>
+          <a:prstDash val="solid"/>
+        </a:ln>
+        <a:effectLst/>
+      </dsp:spPr>
+      <dsp:style>
+        <a:lnRef idx="2">
+          <a:scrgbClr r="0" g="0" b="0"/>
+        </a:lnRef>
+        <a:fillRef idx="1">
+          <a:scrgbClr r="0" g="0" b="0"/>
+        </a:fillRef>
+        <a:effectRef idx="0">
+          <a:scrgbClr r="0" g="0" b="0"/>
+        </a:effectRef>
+        <a:fontRef idx="minor">
+          <a:schemeClr val="lt1"/>
+        </a:fontRef>
+      </dsp:style>
+      <dsp:txBody>
+        <a:bodyPr spcFirstLastPara="0" vert="horz" wrap="square" lIns="180512" tIns="72390" rIns="135128" bIns="72390" numCol="1" spcCol="1270" anchor="ctr" anchorCtr="0">
+          <a:noAutofit/>
+        </a:bodyPr>
+        <a:lstStyle/>
+        <a:p>
+          <a:pPr marL="0" lvl="0" indent="0" algn="ctr" defTabSz="844550">
+            <a:lnSpc>
+              <a:spcPct val="90000"/>
+            </a:lnSpc>
+            <a:spcBef>
+              <a:spcPct val="0"/>
+            </a:spcBef>
+            <a:spcAft>
+              <a:spcPct val="35000"/>
+            </a:spcAft>
+            <a:buNone/>
+          </a:pPr>
+          <a:r>
+            <a:rPr lang="en-GB" sz="1900" kern="1200" dirty="0" err="1"/>
+            <a:t>Conclusioni</a:t>
+          </a:r>
+          <a:endParaRPr lang="en-GB" sz="1900" kern="1200" dirty="0"/>
+        </a:p>
+      </dsp:txBody>
+      <dsp:txXfrm rot="10800000">
+        <a:off x="102336" y="3190679"/>
+        <a:ext cx="7842210" cy="409349"/>
+      </dsp:txXfrm>
+    </dsp:sp>
+    <dsp:sp modelId="{3B5A8344-2F5A-DE49-97B1-00D7C60CFA26}">
+      <dsp:nvSpPr>
+        <dsp:cNvPr id="0" name=""/>
+        <dsp:cNvSpPr/>
+      </dsp:nvSpPr>
+      <dsp:spPr>
+        <a:xfrm>
+          <a:off x="0" y="3191050"/>
+          <a:ext cx="409349" cy="409349"/>
+        </a:xfrm>
+        <a:prstGeom prst="ellipse">
+          <a:avLst/>
+        </a:prstGeom>
+        <a:solidFill>
+          <a:schemeClr val="accent6">
+            <a:lumMod val="20000"/>
+            <a:lumOff val="80000"/>
+          </a:schemeClr>
+        </a:solidFill>
+        <a:ln w="25400" cap="flat" cmpd="sng" algn="ctr">
+          <a:solidFill>
+            <a:schemeClr val="lt1">
+              <a:hueOff val="0"/>
+              <a:satOff val="0"/>
+              <a:lumOff val="0"/>
+              <a:alphaOff val="0"/>
+            </a:schemeClr>
+          </a:solidFill>
+          <a:prstDash val="solid"/>
+        </a:ln>
+        <a:effectLst/>
+      </dsp:spPr>
+      <dsp:style>
+        <a:lnRef idx="2">
+          <a:scrgbClr r="0" g="0" b="0"/>
+        </a:lnRef>
+        <a:fillRef idx="1">
+          <a:scrgbClr r="0" g="0" b="0"/>
+        </a:fillRef>
+        <a:effectRef idx="0">
+          <a:scrgbClr r="0" g="0" b="0"/>
+        </a:effectRef>
+        <a:fontRef idx="minor"/>
+      </dsp:style>
+    </dsp:sp>
+  </dsp:spTree>
+</dsp:drawing>
+</file>
+
+<file path=ppt/diagrams/layout1.xml><?xml version="1.0" encoding="utf-8"?>
+<dgm:layoutDef xmlns:dgm="http://schemas.openxmlformats.org/drawingml/2006/diagram" xmlns:a="http://schemas.openxmlformats.org/drawingml/2006/main" uniqueId="urn:microsoft.com/office/officeart/2005/8/layout/vList3">
+  <dgm:title val=""/>
+  <dgm:desc val=""/>
+  <dgm:catLst>
+    <dgm:cat type="list" pri="14000"/>
+    <dgm:cat type="convert" pri="3000"/>
+    <dgm:cat type="picture" pri="27000"/>
+    <dgm:cat type="pictureconvert" pri="27000"/>
+  </dgm:catLst>
+  <dgm:sampData useDef="1">
+    <dgm:dataModel>
+      <dgm:ptLst/>
+      <dgm:bg/>
+      <dgm:whole/>
+    </dgm:dataModel>
+  </dgm:sampData>
+  <dgm:styleData>
+    <dgm:dataModel>
+      <dgm:ptLst>
+        <dgm:pt modelId="0" type="doc"/>
+        <dgm:pt modelId="1"/>
+        <dgm:pt modelId="2"/>
+      </dgm:ptLst>
+      <dgm:cxnLst>
+        <dgm:cxn modelId="3" srcId="0" destId="1" srcOrd="0" destOrd="0"/>
+        <dgm:cxn modelId="4" srcId="0" destId="2" srcOrd="1" destOrd="0"/>
+      </dgm:cxnLst>
+      <dgm:bg/>
+      <dgm:whole/>
+    </dgm:dataModel>
+  </dgm:styleData>
+  <dgm:clrData>
+    <dgm:dataModel>
+      <dgm:ptLst>
+        <dgm:pt modelId="0" type="doc"/>
+        <dgm:pt modelId="1"/>
+        <dgm:pt modelId="2"/>
+        <dgm:pt modelId="3"/>
+        <dgm:pt modelId="4"/>
+      </dgm:ptLst>
+      <dgm:cxnLst>
+        <dgm:cxn modelId="5" srcId="0" destId="1" srcOrd="0" destOrd="0"/>
+        <dgm:cxn modelId="6" srcId="0" destId="2" srcOrd="1" destOrd="0"/>
+        <dgm:cxn modelId="7" srcId="0" destId="3" srcOrd="2" destOrd="0"/>
+        <dgm:cxn modelId="8" srcId="0" destId="4" srcOrd="3" destOrd="0"/>
+      </dgm:cxnLst>
+      <dgm:bg/>
+      <dgm:whole/>
+    </dgm:dataModel>
+  </dgm:clrData>
+  <dgm:layoutNode name="linearFlow">
+    <dgm:varLst>
+      <dgm:dir/>
+      <dgm:resizeHandles val="exact"/>
+    </dgm:varLst>
+    <dgm:alg type="lin">
+      <dgm:param type="linDir" val="fromT"/>
+      <dgm:param type="vertAlign" val="mid"/>
+      <dgm:param type="horzAlign" val="ctr"/>
+    </dgm:alg>
+    <dgm:shape xmlns:r="http://schemas.openxmlformats.org/officeDocument/2006/relationships" r:blip="">
+      <dgm:adjLst/>
+    </dgm:shape>
+    <dgm:presOf/>
+    <dgm:constrLst>
+      <dgm:constr type="w" for="ch" forName="composite" refType="w"/>
+      <dgm:constr type="h" for="ch" forName="composite" refType="h"/>
+      <dgm:constr type="h" for="ch" forName="spacing" refType="h" refFor="ch" refForName="composite" fact="0.25"/>
+      <dgm:constr type="h" for="ch" forName="spacing" refType="w" op="lte" fact="0.1"/>
+      <dgm:constr type="primFontSz" for="des" ptType="node" op="equ" val="65"/>
+    </dgm:constrLst>
+    <dgm:ruleLst/>
+    <dgm:forEach name="Name0" axis="ch" ptType="node">
+      <dgm:layoutNode name="composite">
+        <dgm:alg type="composite"/>
+        <dgm:shape xmlns:r="http://schemas.openxmlformats.org/officeDocument/2006/relationships" r:blip="">
+          <dgm:adjLst/>
+        </dgm:shape>
+        <dgm:presOf/>
+        <dgm:choose name="Name1">
+          <dgm:if name="Name2" func="var" arg="dir" op="equ" val="norm">
+            <dgm:constrLst>
+              <dgm:constr type="w" for="ch" forName="imgShp" refType="w" fact="0.335"/>
+              <dgm:constr type="h" for="ch" forName="imgShp" refType="w" refFor="ch" refForName="imgShp" op="equ"/>
+              <dgm:constr type="h" for="ch" forName="imgShp" refType="h" op="lte"/>
+              <dgm:constr type="ctrY" for="ch" forName="imgShp" refType="h" fact="0.5"/>
+              <dgm:constr type="l" for="ch" forName="imgShp"/>
+              <dgm:constr type="w" for="ch" forName="txShp" refType="w" op="equ" fact="0.665"/>
+              <dgm:constr type="h" for="ch" forName="txShp" refType="h" refFor="ch" refForName="imgShp" op="equ"/>
+              <dgm:constr type="ctrY" for="ch" forName="txShp" refType="h" fact="0.5"/>
+              <dgm:constr type="l" for="ch" forName="txShp" refType="w" refFor="ch" refForName="imgShp" fact="0.5"/>
+              <dgm:constr type="lMarg" for="ch" forName="txShp" refType="w" refFor="ch" refForName="imgShp" fact="1.25"/>
+            </dgm:constrLst>
+          </dgm:if>
+          <dgm:else name="Name3">
+            <dgm:constrLst>
+              <dgm:constr type="w" for="ch" forName="imgShp" refType="w" fact="0.335"/>
+              <dgm:constr type="h" for="ch" forName="imgShp" refType="w" refFor="ch" refForName="imgShp" op="equ"/>
+              <dgm:constr type="h" for="ch" forName="imgShp" refType="h" op="lte"/>
+              <dgm:constr type="ctrY" for="ch" forName="imgShp" refType="h" fact="0.5"/>
+              <dgm:constr type="r" for="ch" forName="imgShp" refType="w"/>
+              <dgm:constr type="w" for="ch" forName="txShp" refType="w" op="equ" fact="0.665"/>
+              <dgm:constr type="h" for="ch" forName="txShp" refType="h" refFor="ch" refForName="imgShp" op="equ"/>
+              <dgm:constr type="ctrY" for="ch" forName="txShp" refType="h" fact="0.5"/>
+              <dgm:constr type="r" for="ch" forName="txShp" refType="ctrX" refFor="ch" refForName="imgShp"/>
+              <dgm:constr type="rMarg" for="ch" forName="txShp" refType="w" refFor="ch" refForName="imgShp" fact="1.25"/>
+            </dgm:constrLst>
+          </dgm:else>
+        </dgm:choose>
+        <dgm:ruleLst/>
+        <dgm:layoutNode name="imgShp" styleLbl="fgImgPlace1">
+          <dgm:alg type="sp"/>
+          <dgm:shape xmlns:r="http://schemas.openxmlformats.org/officeDocument/2006/relationships" type="ellipse" r:blip="" blipPhldr="1">
+            <dgm:adjLst/>
+          </dgm:shape>
+          <dgm:presOf/>
+          <dgm:constrLst/>
+          <dgm:ruleLst/>
+        </dgm:layoutNode>
+        <dgm:layoutNode name="txShp">
+          <dgm:varLst>
+            <dgm:bulletEnabled val="1"/>
+          </dgm:varLst>
+          <dgm:alg type="tx"/>
+          <dgm:choose name="Name4">
+            <dgm:if name="Name5" func="var" arg="dir" op="equ" val="norm">
+              <dgm:shape xmlns:r="http://schemas.openxmlformats.org/officeDocument/2006/relationships" rot="180" type="homePlate" r:blip="" zOrderOff="-1">
+                <dgm:adjLst/>
+              </dgm:shape>
+            </dgm:if>
+            <dgm:else name="Name6">
+              <dgm:shape xmlns:r="http://schemas.openxmlformats.org/officeDocument/2006/relationships" type="homePlate" r:blip="" zOrderOff="-1">
+                <dgm:adjLst/>
+              </dgm:shape>
+            </dgm:else>
+          </dgm:choose>
+          <dgm:presOf axis="desOrSelf" ptType="node"/>
+          <dgm:constrLst>
+            <dgm:constr type="tMarg" refType="primFontSz" fact="0.3"/>
+            <dgm:constr type="bMarg" refType="primFontSz" fact="0.3"/>
+          </dgm:constrLst>
+          <dgm:ruleLst>
+            <dgm:rule type="primFontSz" val="5" fact="NaN" max="NaN"/>
+          </dgm:ruleLst>
+        </dgm:layoutNode>
+      </dgm:layoutNode>
+      <dgm:forEach name="Name7" axis="followSib" ptType="sibTrans" cnt="1">
+        <dgm:layoutNode name="spacing">
+          <dgm:alg type="sp"/>
+          <dgm:shape xmlns:r="http://schemas.openxmlformats.org/officeDocument/2006/relationships" r:blip="">
+            <dgm:adjLst/>
+          </dgm:shape>
+          <dgm:presOf axis="self"/>
+          <dgm:constrLst/>
+          <dgm:ruleLst/>
+        </dgm:layoutNode>
+      </dgm:forEach>
+    </dgm:forEach>
+  </dgm:layoutNode>
+</dgm:layoutDef>
+</file>
+
+<file path=ppt/diagrams/quickStyle1.xml><?xml version="1.0" encoding="utf-8"?>
+<dgm:styleDef xmlns:dgm="http://schemas.openxmlformats.org/drawingml/2006/diagram" xmlns:a="http://schemas.openxmlformats.org/drawingml/2006/main" uniqueId="urn:microsoft.com/office/officeart/2005/8/quickstyle/simple1">
+  <dgm:title val=""/>
+  <dgm:desc val=""/>
+  <dgm:catLst>
+    <dgm:cat type="simple" pri="10100"/>
+  </dgm:catLst>
+  <dgm:scene3d>
+    <a:camera prst="orthographicFront"/>
+    <a:lightRig rig="threePt" dir="t"/>
+  </dgm:scene3d>
+  <dgm:styleLbl name="node0">
+    <dgm:scene3d>
+      <a:camera prst="orthographicFront"/>
+      <a:lightRig rig="threePt" dir="t"/>
+    </dgm:scene3d>
+    <dgm:sp3d/>
+    <dgm:txPr/>
+    <dgm:style>
+      <a:lnRef idx="2">
+        <a:scrgbClr r="0" g="0" b="0"/>
+      </a:lnRef>
+      <a:fillRef idx="1">
+        <a:scrgbClr r="0" g="0" b="0"/>
+      </a:fillRef>
+      <a:effectRef idx="0">
+        <a:scrgbClr r="0" g="0" b="0"/>
+      </a:effectRef>
+      <a:fontRef idx="minor">
+        <a:schemeClr val="lt1"/>
+      </a:fontRef>
+    </dgm:style>
+  </dgm:styleLbl>
+  <dgm:styleLbl name="lnNode1">
+    <dgm:scene3d>
+      <a:camera prst="orthographicFront"/>
+      <a:lightRig rig="threePt" dir="t"/>
+    </dgm:scene3d>
+    <dgm:sp3d/>
+    <dgm:txPr/>
+    <dgm:style>
+      <a:lnRef idx="2">
+        <a:scrgbClr r="0" g="0" b="0"/>
+      </a:lnRef>
+      <a:fillRef idx="1">
+        <a:scrgbClr r="0" g="0" b="0"/>
+      </a:fillRef>
+      <a:effectRef idx="0">
+        <a:scrgbClr r="0" g="0" b="0"/>
+      </a:effectRef>
+      <a:fontRef idx="minor">
+        <a:schemeClr val="lt1"/>
+      </a:fontRef>
+    </dgm:style>
+  </dgm:styleLbl>
+  <dgm:styleLbl name="vennNode1">
+    <dgm:scene3d>
+      <a:camera prst="orthographicFront"/>
+      <a:lightRig rig="threePt" dir="t"/>
+    </dgm:scene3d>
+    <dgm:sp3d/>
+    <dgm:txPr/>
+    <dgm:style>
+      <a:lnRef idx="2">
+        <a:scrgbClr r="0" g="0" b="0"/>
+      </a:lnRef>
+      <a:fillRef idx="1">
+        <a:scrgbClr r="0" g="0" b="0"/>
+      </a:fillRef>
+      <a:effectRef idx="0">
+        <a:scrgbClr r="0" g="0" b="0"/>
+      </a:effectRef>
+      <a:fontRef idx="minor">
+        <a:schemeClr val="tx1"/>
+      </a:fontRef>
+    </dgm:style>
+  </dgm:styleLbl>
+  <dgm:styleLbl name="alignNode1">
+    <dgm:scene3d>
+      <a:camera prst="orthographicFront"/>
+      <a:lightRig rig="threePt" dir="t"/>
+    </dgm:scene3d>
+    <dgm:sp3d/>
+    <dgm:txPr/>
+    <dgm:style>
+      <a:lnRef idx="2">
+        <a:scrgbClr r="0" g="0" b="0"/>
+      </a:lnRef>
+      <a:fillRef idx="1">
+        <a:scrgbClr r="0" g="0" b="0"/>
+      </a:fillRef>
+      <a:effectRef idx="0">
+        <a:scrgbClr r="0" g="0" b="0"/>
+      </a:effectRef>
+      <a:fontRef idx="minor">
+        <a:schemeClr val="lt1"/>
+      </a:fontRef>
+    </dgm:style>
+  </dgm:styleLbl>
+  <dgm:styleLbl name="node1">
+    <dgm:scene3d>
+      <a:camera prst="orthographicFront"/>
+      <a:lightRig rig="threePt" dir="t"/>
+    </dgm:scene3d>
+    <dgm:sp3d/>
+    <dgm:txPr/>
+    <dgm:style>
+      <a:lnRef idx="2">
+        <a:scrgbClr r="0" g="0" b="0"/>
+      </a:lnRef>
+      <a:fillRef idx="1">
+        <a:scrgbClr r="0" g="0" b="0"/>
+      </a:fillRef>
+      <a:effectRef idx="0">
+        <a:scrgbClr r="0" g="0" b="0"/>
+      </a:effectRef>
+      <a:fontRef idx="minor">
+        <a:schemeClr val="lt1"/>
+      </a:fontRef>
+    </dgm:style>
+  </dgm:styleLbl>
+  <dgm:styleLbl name="node2">
+    <dgm:scene3d>
+      <a:camera prst="orthographicFront"/>
+      <a:lightRig rig="threePt" dir="t"/>
+    </dgm:scene3d>
+    <dgm:sp3d/>
+    <dgm:txPr/>
+    <dgm:style>
+      <a:lnRef idx="2">
+        <a:scrgbClr r="0" g="0" b="0"/>
+      </a:lnRef>
+      <a:fillRef idx="1">
+        <a:scrgbClr r="0" g="0" b="0"/>
+      </a:fillRef>
+      <a:effectRef idx="0">
+        <a:scrgbClr r="0" g="0" b="0"/>
+      </a:effectRef>
+      <a:fontRef idx="minor">
+        <a:schemeClr val="lt1"/>
+      </a:fontRef>
+    </dgm:style>
+  </dgm:styleLbl>
+  <dgm:styleLbl name="node3">
+    <dgm:scene3d>
+      <a:camera prst="orthographicFront"/>
+      <a:lightRig rig="threePt" dir="t"/>
+    </dgm:scene3d>
+    <dgm:sp3d/>
+    <dgm:txPr/>
+    <dgm:style>
+      <a:lnRef idx="2">
+        <a:scrgbClr r="0" g="0" b="0"/>
+      </a:lnRef>
+      <a:fillRef idx="1">
+        <a:scrgbClr r="0" g="0" b="0"/>
+      </a:fillRef>
+      <a:effectRef idx="0">
+        <a:scrgbClr r="0" g="0" b="0"/>
+      </a:effectRef>
+      <a:fontRef idx="minor">
+        <a:schemeClr val="lt1"/>
+      </a:fontRef>
+    </dgm:style>
+  </dgm:styleLbl>
+  <dgm:styleLbl name="node4">
+    <dgm:scene3d>
+      <a:camera prst="orthographicFront"/>
+      <a:lightRig rig="threePt" dir="t"/>
+    </dgm:scene3d>
+    <dgm:sp3d/>
+    <dgm:txPr/>
+    <dgm:style>
+      <a:lnRef idx="2">
+        <a:scrgbClr r="0" g="0" b="0"/>
+      </a:lnRef>
+      <a:fillRef idx="1">
+        <a:scrgbClr r="0" g="0" b="0"/>
+      </a:fillRef>
+      <a:effectRef idx="0">
+        <a:scrgbClr r="0" g="0" b="0"/>
+      </a:effectRef>
+      <a:fontRef idx="minor">
+        <a:schemeClr val="lt1"/>
+      </a:fontRef>
+    </dgm:style>
+  </dgm:styleLbl>
+  <dgm:styleLbl name="fgImgPlace1">
+    <dgm:scene3d>
+      <a:camera prst="orthographicFront"/>
+      <a:lightRig rig="threePt" dir="t"/>
+    </dgm:scene3d>
+    <dgm:sp3d/>
+    <dgm:txPr/>
+    <dgm:style>
+      <a:lnRef idx="2">
+        <a:scrgbClr r="0" g="0" b="0"/>
+      </a:lnRef>
+      <a:fillRef idx="1">
+        <a:scrgbClr r="0" g="0" b="0"/>
+      </a:fillRef>
+      <a:effectRef idx="0">
+        <a:scrgbClr r="0" g="0" b="0"/>
+      </a:effectRef>
+      <a:fontRef idx="minor"/>
+    </dgm:style>
+  </dgm:styleLbl>
+  <dgm:styleLbl name="alignImgPlace1">
+    <dgm:scene3d>
+      <a:camera prst="orthographicFront"/>
+      <a:lightRig rig="threePt" dir="t"/>
+    </dgm:scene3d>
+    <dgm:sp3d/>
+    <dgm:txPr/>
+    <dgm:style>
+      <a:lnRef idx="2">
+        <a:scrgbClr r="0" g="0" b="0"/>
+      </a:lnRef>
+      <a:fillRef idx="1">
+        <a:scrgbClr r="0" g="0" b="0"/>
+      </a:fillRef>
+      <a:effectRef idx="0">
+        <a:scrgbClr r="0" g="0" b="0"/>
+      </a:effectRef>
+      <a:fontRef idx="minor"/>
+    </dgm:style>
+  </dgm:styleLbl>
+  <dgm:styleLbl name="bgImgPlace1">
+    <dgm:scene3d>
+      <a:camera prst="orthographicFront"/>
+      <a:lightRig rig="threePt" dir="t"/>
+    </dgm:scene3d>
+    <dgm:sp3d/>
+    <dgm:txPr/>
+    <dgm:style>
+      <a:lnRef idx="2">
+        <a:scrgbClr r="0" g="0" b="0"/>
+      </a:lnRef>
+      <a:fillRef idx="1">
+        <a:scrgbClr r="0" g="0" b="0"/>
+      </a:fillRef>
+      <a:effectRef idx="0">
+        <a:scrgbClr r="0" g="0" b="0"/>
+      </a:effectRef>
+      <a:fontRef idx="minor"/>
+    </dgm:style>
+  </dgm:styleLbl>
+  <dgm:styleLbl name="sibTrans2D1">
+    <dgm:scene3d>
+      <a:camera prst="orthographicFront"/>
+      <a:lightRig rig="threePt" dir="t"/>
+    </dgm:scene3d>
+    <dgm:sp3d/>
+    <dgm:txPr/>
+    <dgm:style>
+      <a:lnRef idx="0">
+        <a:scrgbClr r="0" g="0" b="0"/>
+      </a:lnRef>
+      <a:fillRef idx="1">
+        <a:scrgbClr r="0" g="0" b="0"/>
+      </a:fillRef>
+      <a:effectRef idx="0">
+        <a:scrgbClr r="0" g="0" b="0"/>
+      </a:effectRef>
+      <a:fontRef idx="minor">
+        <a:schemeClr val="lt1"/>
+      </a:fontRef>
+    </dgm:style>
+  </dgm:styleLbl>
+  <dgm:styleLbl name="fgSibTrans2D1">
+    <dgm:scene3d>
+      <a:camera prst="orthographicFront"/>
+      <a:lightRig rig="threePt" dir="t"/>
+    </dgm:scene3d>
+    <dgm:sp3d/>
+    <dgm:txPr/>
+    <dgm:style>
+      <a:lnRef idx="0">
+        <a:scrgbClr r="0" g="0" b="0"/>
+      </a:lnRef>
+      <a:fillRef idx="1">
+        <a:scrgbClr r="0" g="0" b="0"/>
+      </a:fillRef>
+      <a:effectRef idx="0">
+        <a:scrgbClr r="0" g="0" b="0"/>
+      </a:effectRef>
+      <a:fontRef idx="minor">
+        <a:schemeClr val="lt1"/>
+      </a:fontRef>
+    </dgm:style>
+  </dgm:styleLbl>
+  <dgm:styleLbl name="bgSibTrans2D1">
+    <dgm:scene3d>
+      <a:camera prst="orthographicFront"/>
+      <a:lightRig rig="threePt" dir="t"/>
+    </dgm:scene3d>
+    <dgm:sp3d/>
+    <dgm:txPr/>
+    <dgm:style>
+      <a:lnRef idx="0">
+        <a:scrgbClr r="0" g="0" b="0"/>
+      </a:lnRef>
+      <a:fillRef idx="1">
+        <a:scrgbClr r="0" g="0" b="0"/>
+      </a:fillRef>
+      <a:effectRef idx="0">
+        <a:scrgbClr r="0" g="0" b="0"/>
+      </a:effectRef>
+      <a:fontRef idx="minor">
+        <a:schemeClr val="lt1"/>
+      </a:fontRef>
+    </dgm:style>
+  </dgm:styleLbl>
+  <dgm:styleLbl name="sibTrans1D1">
+    <dgm:scene3d>
+      <a:camera prst="orthographicFront"/>
+      <a:lightRig rig="threePt" dir="t"/>
+    </dgm:scene3d>
+    <dgm:sp3d/>
+    <dgm:txPr/>
+    <dgm:style>
+      <a:lnRef idx="1">
+        <a:scrgbClr r="0" g="0" b="0"/>
+      </a:lnRef>
+      <a:fillRef idx="0">
+        <a:scrgbClr r="0" g="0" b="0"/>
+      </a:fillRef>
+      <a:effectRef idx="0">
+        <a:scrgbClr r="0" g="0" b="0"/>
+      </a:effectRef>
+      <a:fontRef idx="minor"/>
+    </dgm:style>
+  </dgm:styleLbl>
+  <dgm:styleLbl name="callout">
+    <dgm:scene3d>
+      <a:camera prst="orthographicFront"/>
+      <a:lightRig rig="threePt" dir="t"/>
+    </dgm:scene3d>
+    <dgm:sp3d/>
+    <dgm:txPr/>
+    <dgm:style>
+      <a:lnRef idx="2">
+        <a:scrgbClr r="0" g="0" b="0"/>
+      </a:lnRef>
+      <a:fillRef idx="1">
+        <a:scrgbClr r="0" g="0" b="0"/>
+      </a:fillRef>
+      <a:effectRef idx="0">
+        <a:scrgbClr r="0" g="0" b="0"/>
+      </a:effectRef>
+      <a:fontRef idx="minor"/>
+    </dgm:style>
+  </dgm:styleLbl>
+  <dgm:styleLbl name="asst0">
+    <dgm:scene3d>
+      <a:camera prst="orthographicFront"/>
+      <a:lightRig rig="threePt" dir="t"/>
+    </dgm:scene3d>
+    <dgm:sp3d/>
+    <dgm:txPr/>
+    <dgm:style>
+      <a:lnRef idx="2">
+        <a:scrgbClr r="0" g="0" b="0"/>
+      </a:lnRef>
+      <a:fillRef idx="1">
+        <a:scrgbClr r="0" g="0" b="0"/>
+      </a:fillRef>
+      <a:effectRef idx="0">
+        <a:scrgbClr r="0" g="0" b="0"/>
+      </a:effectRef>
+      <a:fontRef idx="minor">
+        <a:schemeClr val="lt1"/>
+      </a:fontRef>
+    </dgm:style>
+  </dgm:styleLbl>
+  <dgm:styleLbl name="asst1">
+    <dgm:scene3d>
+      <a:camera prst="orthographicFront"/>
+      <a:lightRig rig="threePt" dir="t"/>
+    </dgm:scene3d>
+    <dgm:sp3d/>
+    <dgm:txPr/>
+    <dgm:style>
+      <a:lnRef idx="2">
+        <a:scrgbClr r="0" g="0" b="0"/>
+      </a:lnRef>
+      <a:fillRef idx="1">
+        <a:scrgbClr r="0" g="0" b="0"/>
+      </a:fillRef>
+      <a:effectRef idx="0">
+        <a:scrgbClr r="0" g="0" b="0"/>
+      </a:effectRef>
+      <a:fontRef idx="minor">
+        <a:schemeClr val="lt1"/>
+      </a:fontRef>
+    </dgm:style>
+  </dgm:styleLbl>
+  <dgm:styleLbl name="asst2">
+    <dgm:scene3d>
+      <a:camera prst="orthographicFront"/>
+      <a:lightRig rig="threePt" dir="t"/>
+    </dgm:scene3d>
+    <dgm:sp3d/>
+    <dgm:txPr/>
+    <dgm:style>
+      <a:lnRef idx="2">
+        <a:scrgbClr r="0" g="0" b="0"/>
+      </a:lnRef>
+      <a:fillRef idx="1">
+        <a:scrgbClr r="0" g="0" b="0"/>
+      </a:fillRef>
+      <a:effectRef idx="0">
+        <a:scrgbClr r="0" g="0" b="0"/>
+      </a:effectRef>
+      <a:fontRef idx="minor">
+        <a:schemeClr val="lt1"/>
+      </a:fontRef>
+    </dgm:style>
+  </dgm:styleLbl>
+  <dgm:styleLbl name="asst3">
+    <dgm:scene3d>
+      <a:camera prst="orthographicFront"/>
+      <a:lightRig rig="threePt" dir="t"/>
+    </dgm:scene3d>
+    <dgm:sp3d/>
+    <dgm:txPr/>
+    <dgm:style>
+      <a:lnRef idx="2">
+        <a:scrgbClr r="0" g="0" b="0"/>
+      </a:lnRef>
+      <a:fillRef idx="1">
+        <a:scrgbClr r="0" g="0" b="0"/>
+      </a:fillRef>
+      <a:effectRef idx="0">
+        <a:scrgbClr r="0" g="0" b="0"/>
+      </a:effectRef>
+      <a:fontRef idx="minor">
+        <a:schemeClr val="lt1"/>
+      </a:fontRef>
+    </dgm:style>
+  </dgm:styleLbl>
+  <dgm:styleLbl name="asst4">
+    <dgm:scene3d>
+      <a:camera prst="orthographicFront"/>
+      <a:lightRig rig="threePt" dir="t"/>
+    </dgm:scene3d>
+    <dgm:sp3d/>
+    <dgm:txPr/>
+    <dgm:style>
+      <a:lnRef idx="2">
+        <a:scrgbClr r="0" g="0" b="0"/>
+      </a:lnRef>
+      <a:fillRef idx="1">
+        <a:scrgbClr r="0" g="0" b="0"/>
+      </a:fillRef>
+      <a:effectRef idx="0">
+        <a:scrgbClr r="0" g="0" b="0"/>
+      </a:effectRef>
+      <a:fontRef idx="minor">
+        <a:schemeClr val="lt1"/>
+      </a:fontRef>
+    </dgm:style>
+  </dgm:styleLbl>
+  <dgm:styleLbl name="parChTrans2D1">
+    <dgm:scene3d>
+      <a:camera prst="orthographicFront"/>
+      <a:lightRig rig="threePt" dir="t"/>
+    </dgm:scene3d>
+    <dgm:sp3d/>
+    <dgm:txPr/>
+    <dgm:style>
+      <a:lnRef idx="2">
+        <a:scrgbClr r="0" g="0" b="0"/>
+      </a:lnRef>
+      <a:fillRef idx="1">
+        <a:scrgbClr r="0" g="0" b="0"/>
+      </a:fillRef>
+      <a:effectRef idx="0">
+        <a:scrgbClr r="0" g="0" b="0"/>
+      </a:effectRef>
+      <a:fontRef idx="minor">
+        <a:schemeClr val="lt1"/>
+      </a:fontRef>
+    </dgm:style>
+  </dgm:styleLbl>
+  <dgm:styleLbl name="parChTrans2D2">
+    <dgm:scene3d>
+      <a:camera prst="orthographicFront"/>
+      <a:lightRig rig="threePt" dir="t"/>
+    </dgm:scene3d>
+    <dgm:sp3d/>
+    <dgm:txPr/>
+    <dgm:style>
+      <a:lnRef idx="2">
+        <a:scrgbClr r="0" g="0" b="0"/>
+      </a:lnRef>
+      <a:fillRef idx="1">
+        <a:scrgbClr r="0" g="0" b="0"/>
+      </a:fillRef>
+      <a:effectRef idx="0">
+        <a:scrgbClr r="0" g="0" b="0"/>
+      </a:effectRef>
+      <a:fontRef idx="minor">
+        <a:schemeClr val="lt1"/>
+      </a:fontRef>
+    </dgm:style>
+  </dgm:styleLbl>
+  <dgm:styleLbl name="parChTrans2D3">
+    <dgm:scene3d>
+      <a:camera prst="orthographicFront"/>
+      <a:lightRig rig="threePt" dir="t"/>
+    </dgm:scene3d>
+    <dgm:sp3d/>
+    <dgm:txPr/>
+    <dgm:style>
+      <a:lnRef idx="2">
+        <a:scrgbClr r="0" g="0" b="0"/>
+      </a:lnRef>
+      <a:fillRef idx="1">
+        <a:scrgbClr r="0" g="0" b="0"/>
+      </a:fillRef>
+      <a:effectRef idx="0">
+        <a:scrgbClr r="0" g="0" b="0"/>
+      </a:effectRef>
+      <a:fontRef idx="minor">
+        <a:schemeClr val="lt1"/>
+      </a:fontRef>
+    </dgm:style>
+  </dgm:styleLbl>
+  <dgm:styleLbl name="parChTrans2D4">
+    <dgm:scene3d>
+      <a:camera prst="orthographicFront"/>
+      <a:lightRig rig="threePt" dir="t"/>
+    </dgm:scene3d>
+    <dgm:sp3d/>
+    <dgm:txPr/>
+    <dgm:style>
+      <a:lnRef idx="2">
+        <a:scrgbClr r="0" g="0" b="0"/>
+      </a:lnRef>
+      <a:fillRef idx="1">
+        <a:scrgbClr r="0" g="0" b="0"/>
+      </a:fillRef>
+      <a:effectRef idx="0">
+        <a:scrgbClr r="0" g="0" b="0"/>
+      </a:effectRef>
+      <a:fontRef idx="minor">
+        <a:schemeClr val="lt1"/>
+      </a:fontRef>
+    </dgm:style>
+  </dgm:styleLbl>
+  <dgm:styleLbl name="parChTrans1D1">
+    <dgm:scene3d>
+      <a:camera prst="orthographicFront"/>
+      <a:lightRig rig="threePt" dir="t"/>
+    </dgm:scene3d>
+    <dgm:sp3d/>
+    <dgm:txPr/>
+    <dgm:style>
+      <a:lnRef idx="2">
+        <a:scrgbClr r="0" g="0" b="0"/>
+      </a:lnRef>
+      <a:fillRef idx="0">
+        <a:scrgbClr r="0" g="0" b="0"/>
+      </a:fillRef>
+      <a:effectRef idx="0">
+        <a:scrgbClr r="0" g="0" b="0"/>
+      </a:effectRef>
+      <a:fontRef idx="minor"/>
+    </dgm:style>
+  </dgm:styleLbl>
+  <dgm:styleLbl name="parChTrans1D2">
+    <dgm:scene3d>
+      <a:camera prst="orthographicFront"/>
+      <a:lightRig rig="threePt" dir="t"/>
+    </dgm:scene3d>
+    <dgm:sp3d/>
+    <dgm:txPr/>
+    <dgm:style>
+      <a:lnRef idx="2">
+        <a:scrgbClr r="0" g="0" b="0"/>
+      </a:lnRef>
+      <a:fillRef idx="0">
+        <a:scrgbClr r="0" g="0" b="0"/>
+      </a:fillRef>
+      <a:effectRef idx="0">
+        <a:scrgbClr r="0" g="0" b="0"/>
+      </a:effectRef>
+      <a:fontRef idx="minor"/>
+    </dgm:style>
+  </dgm:styleLbl>
+  <dgm:styleLbl name="parChTrans1D3">
+    <dgm:scene3d>
+      <a:camera prst="orthographicFront"/>
+      <a:lightRig rig="threePt" dir="t"/>
+    </dgm:scene3d>
+    <dgm:sp3d/>
+    <dgm:txPr/>
+    <dgm:style>
+      <a:lnRef idx="2">
+        <a:scrgbClr r="0" g="0" b="0"/>
+      </a:lnRef>
+      <a:fillRef idx="0">
+        <a:scrgbClr r="0" g="0" b="0"/>
+      </a:fillRef>
+      <a:effectRef idx="0">
+        <a:scrgbClr r="0" g="0" b="0"/>
+      </a:effectRef>
+      <a:fontRef idx="minor"/>
+    </dgm:style>
+  </dgm:styleLbl>
+  <dgm:styleLbl name="parChTrans1D4">
+    <dgm:scene3d>
+      <a:camera prst="orthographicFront"/>
+      <a:lightRig rig="threePt" dir="t"/>
+    </dgm:scene3d>
+    <dgm:sp3d/>
+    <dgm:txPr/>
+    <dgm:style>
+      <a:lnRef idx="2">
+        <a:scrgbClr r="0" g="0" b="0"/>
+      </a:lnRef>
+      <a:fillRef idx="0">
+        <a:scrgbClr r="0" g="0" b="0"/>
+      </a:fillRef>
+      <a:effectRef idx="0">
+        <a:scrgbClr r="0" g="0" b="0"/>
+      </a:effectRef>
+      <a:fontRef idx="minor"/>
+    </dgm:style>
+  </dgm:styleLbl>
+  <dgm:styleLbl name="fgAcc1">
+    <dgm:scene3d>
+      <a:camera prst="orthographicFront"/>
+      <a:lightRig rig="threePt" dir="t"/>
+    </dgm:scene3d>
+    <dgm:sp3d/>
+    <dgm:txPr/>
+    <dgm:style>
+      <a:lnRef idx="2">
+        <a:scrgbClr r="0" g="0" b="0"/>
+      </a:lnRef>
+      <a:fillRef idx="1">
+        <a:scrgbClr r="0" g="0" b="0"/>
+      </a:fillRef>
+      <a:effectRef idx="0">
+        <a:scrgbClr r="0" g="0" b="0"/>
+      </a:effectRef>
+      <a:fontRef idx="minor"/>
+    </dgm:style>
+  </dgm:styleLbl>
+  <dgm:styleLbl name="conFgAcc1">
+    <dgm:scene3d>
+      <a:camera prst="orthographicFront"/>
+      <a:lightRig rig="threePt" dir="t"/>
+    </dgm:scene3d>
+    <dgm:sp3d/>
+    <dgm:txPr/>
+    <dgm:style>
+      <a:lnRef idx="2">
+        <a:scrgbClr r="0" g="0" b="0"/>
+      </a:lnRef>
+      <a:fillRef idx="1">
+        <a:scrgbClr r="0" g="0" b="0"/>
+      </a:fillRef>
+      <a:effectRef idx="0">
+        <a:scrgbClr r="0" g="0" b="0"/>
+      </a:effectRef>
+      <a:fontRef idx="minor"/>
+    </dgm:style>
+  </dgm:styleLbl>
+  <dgm:styleLbl name="alignAcc1">
+    <dgm:scene3d>
+      <a:camera prst="orthographicFront"/>
+      <a:lightRig rig="threePt" dir="t"/>
+    </dgm:scene3d>
+    <dgm:sp3d/>
+    <dgm:txPr/>
+    <dgm:style>
+      <a:lnRef idx="2">
+        <a:scrgbClr r="0" g="0" b="0"/>
+      </a:lnRef>
+      <a:fillRef idx="1">
+        <a:scrgbClr r="0" g="0" b="0"/>
+      </a:fillRef>
+      <a:effectRef idx="0">
+        <a:scrgbClr r="0" g="0" b="0"/>
+      </a:effectRef>
+      <a:fontRef idx="minor"/>
+    </dgm:style>
+  </dgm:styleLbl>
+  <dgm:styleLbl name="trAlignAcc1">
+    <dgm:scene3d>
+      <a:camera prst="orthographicFront"/>
+      <a:lightRig rig="threePt" dir="t"/>
+    </dgm:scene3d>
+    <dgm:sp3d/>
+    <dgm:txPr/>
+    <dgm:style>
+      <a:lnRef idx="1">
+        <a:scrgbClr r="0" g="0" b="0"/>
+      </a:lnRef>
+      <a:fillRef idx="1">
+        <a:scrgbClr r="0" g="0" b="0"/>
+      </a:fillRef>
+      <a:effectRef idx="0">
+        <a:scrgbClr r="0" g="0" b="0"/>
+      </a:effectRef>
+      <a:fontRef idx="minor"/>
+    </dgm:style>
+  </dgm:styleLbl>
+  <dgm:styleLbl name="bgAcc1">
+    <dgm:scene3d>
+      <a:camera prst="orthographicFront"/>
+      <a:lightRig rig="threePt" dir="t"/>
+    </dgm:scene3d>
+    <dgm:sp3d/>
+    <dgm:txPr/>
+    <dgm:style>
+      <a:lnRef idx="2">
+        <a:scrgbClr r="0" g="0" b="0"/>
+      </a:lnRef>
+      <a:fillRef idx="1">
+        <a:scrgbClr r="0" g="0" b="0"/>
+      </a:fillRef>
+      <a:effectRef idx="0">
+        <a:scrgbClr r="0" g="0" b="0"/>
+      </a:effectRef>
+      <a:fontRef idx="minor"/>
+    </dgm:style>
+  </dgm:styleLbl>
+  <dgm:styleLbl name="solidFgAcc1">
+    <dgm:scene3d>
+      <a:camera prst="orthographicFront"/>
+      <a:lightRig rig="threePt" dir="t"/>
+    </dgm:scene3d>
+    <dgm:sp3d/>
+    <dgm:txPr/>
+    <dgm:style>
+      <a:lnRef idx="2">
+        <a:scrgbClr r="0" g="0" b="0"/>
+      </a:lnRef>
+      <a:fillRef idx="1">
+        <a:scrgbClr r="0" g="0" b="0"/>
+      </a:fillRef>
+      <a:effectRef idx="0">
+        <a:scrgbClr r="0" g="0" b="0"/>
+      </a:effectRef>
+      <a:fontRef idx="minor"/>
+    </dgm:style>
+  </dgm:styleLbl>
+  <dgm:styleLbl name="solidAlignAcc1">
+    <dgm:scene3d>
+      <a:camera prst="orthographicFront"/>
+      <a:lightRig rig="threePt" dir="t"/>
+    </dgm:scene3d>
+    <dgm:sp3d/>
+    <dgm:txPr/>
+    <dgm:style>
+      <a:lnRef idx="2">
+        <a:scrgbClr r="0" g="0" b="0"/>
+      </a:lnRef>
+      <a:fillRef idx="1">
+        <a:scrgbClr r="0" g="0" b="0"/>
+      </a:fillRef>
+      <a:effectRef idx="0">
+        <a:scrgbClr r="0" g="0" b="0"/>
+      </a:effectRef>
+      <a:fontRef idx="minor"/>
+    </dgm:style>
+  </dgm:styleLbl>
+  <dgm:styleLbl name="solidBgAcc1">
+    <dgm:scene3d>
+      <a:camera prst="orthographicFront"/>
+      <a:lightRig rig="threePt" dir="t"/>
+    </dgm:scene3d>
+    <dgm:sp3d/>
+    <dgm:txPr/>
+    <dgm:style>
+      <a:lnRef idx="2">
+        <a:scrgbClr r="0" g="0" b="0"/>
+      </a:lnRef>
+      <a:fillRef idx="1">
+        <a:scrgbClr r="0" g="0" b="0"/>
+      </a:fillRef>
+      <a:effectRef idx="0">
+        <a:scrgbClr r="0" g="0" b="0"/>
+      </a:effectRef>
+      <a:fontRef idx="minor"/>
+    </dgm:style>
+  </dgm:styleLbl>
+  <dgm:styleLbl name="fgAccFollowNode1">
+    <dgm:scene3d>
+      <a:camera prst="orthographicFront"/>
+      <a:lightRig rig="threePt" dir="t"/>
+    </dgm:scene3d>
+    <dgm:sp3d/>
+    <dgm:txPr/>
+    <dgm:style>
+      <a:lnRef idx="2">
+        <a:scrgbClr r="0" g="0" b="0"/>
+      </a:lnRef>
+      <a:fillRef idx="1">
+        <a:scrgbClr r="0" g="0" b="0"/>
+      </a:fillRef>
+      <a:effectRef idx="0">
+        <a:scrgbClr r="0" g="0" b="0"/>
+      </a:effectRef>
+      <a:fontRef idx="minor"/>
+    </dgm:style>
+  </dgm:styleLbl>
+  <dgm:styleLbl name="alignAccFollowNode1">
+    <dgm:scene3d>
+      <a:camera prst="orthographicFront"/>
+      <a:lightRig rig="threePt" dir="t"/>
+    </dgm:scene3d>
+    <dgm:sp3d/>
+    <dgm:txPr/>
+    <dgm:style>
+      <a:lnRef idx="2">
+        <a:scrgbClr r="0" g="0" b="0"/>
+      </a:lnRef>
+      <a:fillRef idx="1">
+        <a:scrgbClr r="0" g="0" b="0"/>
+      </a:fillRef>
+      <a:effectRef idx="0">
+        <a:scrgbClr r="0" g="0" b="0"/>
+      </a:effectRef>
+      <a:fontRef idx="minor"/>
+    </dgm:style>
+  </dgm:styleLbl>
+  <dgm:styleLbl name="bgAccFollowNode1">
+    <dgm:scene3d>
+      <a:camera prst="orthographicFront"/>
+      <a:lightRig rig="threePt" dir="t"/>
+    </dgm:scene3d>
+    <dgm:sp3d/>
+    <dgm:txPr/>
+    <dgm:style>
+      <a:lnRef idx="2">
+        <a:scrgbClr r="0" g="0" b="0"/>
+      </a:lnRef>
+      <a:fillRef idx="1">
+        <a:scrgbClr r="0" g="0" b="0"/>
+      </a:fillRef>
+      <a:effectRef idx="0">
+        <a:scrgbClr r="0" g="0" b="0"/>
+      </a:effectRef>
+      <a:fontRef idx="minor"/>
+    </dgm:style>
+  </dgm:styleLbl>
+  <dgm:styleLbl name="fgAcc0">
+    <dgm:scene3d>
+      <a:camera prst="orthographicFront"/>
+      <a:lightRig rig="threePt" dir="t"/>
+    </dgm:scene3d>
+    <dgm:sp3d/>
+    <dgm:txPr/>
+    <dgm:style>
+      <a:lnRef idx="2">
+        <a:scrgbClr r="0" g="0" b="0"/>
+      </a:lnRef>
+      <a:fillRef idx="1">
+        <a:scrgbClr r="0" g="0" b="0"/>
+      </a:fillRef>
+      <a:effectRef idx="0">
+        <a:scrgbClr r="0" g="0" b="0"/>
+      </a:effectRef>
+      <a:fontRef idx="minor"/>
+    </dgm:style>
+  </dgm:styleLbl>
+  <dgm:styleLbl name="fgAcc2">
+    <dgm:scene3d>
+      <a:camera prst="orthographicFront"/>
+      <a:lightRig rig="threePt" dir="t"/>
+    </dgm:scene3d>
+    <dgm:sp3d/>
+    <dgm:txPr/>
+    <dgm:style>
+      <a:lnRef idx="2">
+        <a:scrgbClr r="0" g="0" b="0"/>
+      </a:lnRef>
+      <a:fillRef idx="1">
+        <a:scrgbClr r="0" g="0" b="0"/>
+      </a:fillRef>
+      <a:effectRef idx="0">
+        <a:scrgbClr r="0" g="0" b="0"/>
+      </a:effectRef>
+      <a:fontRef idx="minor"/>
+    </dgm:style>
+  </dgm:styleLbl>
+  <dgm:styleLbl name="fgAcc3">
+    <dgm:scene3d>
+      <a:camera prst="orthographicFront"/>
+      <a:lightRig rig="threePt" dir="t"/>
+    </dgm:scene3d>
+    <dgm:sp3d/>
+    <dgm:txPr/>
+    <dgm:style>
+      <a:lnRef idx="2">
+        <a:scrgbClr r="0" g="0" b="0"/>
+      </a:lnRef>
+      <a:fillRef idx="1">
+        <a:scrgbClr r="0" g="0" b="0"/>
+      </a:fillRef>
+      <a:effectRef idx="0">
+        <a:scrgbClr r="0" g="0" b="0"/>
+      </a:effectRef>
+      <a:fontRef idx="minor"/>
+    </dgm:style>
+  </dgm:styleLbl>
+  <dgm:styleLbl name="fgAcc4">
+    <dgm:scene3d>
+      <a:camera prst="orthographicFront"/>
+      <a:lightRig rig="threePt" dir="t"/>
+    </dgm:scene3d>
+    <dgm:sp3d/>
+    <dgm:txPr/>
+    <dgm:style>
+      <a:lnRef idx="2">
+        <a:scrgbClr r="0" g="0" b="0"/>
+      </a:lnRef>
+      <a:fillRef idx="1">
+        <a:scrgbClr r="0" g="0" b="0"/>
+      </a:fillRef>
+      <a:effectRef idx="0">
+        <a:scrgbClr r="0" g="0" b="0"/>
+      </a:effectRef>
+      <a:fontRef idx="minor"/>
+    </dgm:style>
+  </dgm:styleLbl>
+  <dgm:styleLbl name="bgShp">
+    <dgm:scene3d>
+      <a:camera prst="orthographicFront"/>
+      <a:lightRig rig="threePt" dir="t"/>
+    </dgm:scene3d>
+    <dgm:sp3d/>
+    <dgm:txPr/>
+    <dgm:style>
+      <a:lnRef idx="0">
+        <a:scrgbClr r="0" g="0" b="0"/>
+      </a:lnRef>
+      <a:fillRef idx="1">
+        <a:scrgbClr r="0" g="0" b="0"/>
+      </a:fillRef>
+      <a:effectRef idx="0">
+        <a:scrgbClr r="0" g="0" b="0"/>
+      </a:effectRef>
+      <a:fontRef idx="minor"/>
+    </dgm:style>
+  </dgm:styleLbl>
+  <dgm:styleLbl name="dkBgShp">
+    <dgm:scene3d>
+      <a:camera prst="orthographicFront"/>
+      <a:lightRig rig="threePt" dir="t"/>
+    </dgm:scene3d>
+    <dgm:sp3d/>
+    <dgm:txPr/>
+    <dgm:style>
+      <a:lnRef idx="0">
+        <a:scrgbClr r="0" g="0" b="0"/>
+      </a:lnRef>
+      <a:fillRef idx="1">
+        <a:scrgbClr r="0" g="0" b="0"/>
+      </a:fillRef>
+      <a:effectRef idx="0">
+        <a:scrgbClr r="0" g="0" b="0"/>
+      </a:effectRef>
+      <a:fontRef idx="minor"/>
+    </dgm:style>
+  </dgm:styleLbl>
+  <dgm:styleLbl name="trBgShp">
+    <dgm:scene3d>
+      <a:camera prst="orthographicFront"/>
+      <a:lightRig rig="threePt" dir="t"/>
+    </dgm:scene3d>
+    <dgm:sp3d/>
+    <dgm:txPr/>
+    <dgm:style>
+      <a:lnRef idx="0">
+        <a:scrgbClr r="0" g="0" b="0"/>
+      </a:lnRef>
+      <a:fillRef idx="1">
+        <a:scrgbClr r="0" g="0" b="0"/>
+      </a:fillRef>
+      <a:effectRef idx="0">
+        <a:scrgbClr r="0" g="0" b="0"/>
+      </a:effectRef>
+      <a:fontRef idx="minor"/>
+    </dgm:style>
+  </dgm:styleLbl>
+  <dgm:styleLbl name="fgShp">
+    <dgm:scene3d>
+      <a:camera prst="orthographicFront"/>
+      <a:lightRig rig="threePt" dir="t"/>
+    </dgm:scene3d>
+    <dgm:sp3d/>
+    <dgm:txPr/>
+    <dgm:style>
+      <a:lnRef idx="2">
+        <a:scrgbClr r="0" g="0" b="0"/>
+      </a:lnRef>
+      <a:fillRef idx="1">
+        <a:scrgbClr r="0" g="0" b="0"/>
+      </a:fillRef>
+      <a:effectRef idx="0">
+        <a:scrgbClr r="0" g="0" b="0"/>
+      </a:effectRef>
+      <a:fontRef idx="minor"/>
+    </dgm:style>
+  </dgm:styleLbl>
+  <dgm:styleLbl name="revTx">
+    <dgm:scene3d>
+      <a:camera prst="orthographicFront"/>
+      <a:lightRig rig="threePt" dir="t"/>
+    </dgm:scene3d>
+    <dgm:sp3d/>
+    <dgm:txPr/>
+    <dgm:style>
+      <a:lnRef idx="0">
+        <a:scrgbClr r="0" g="0" b="0"/>
+      </a:lnRef>
+      <a:fillRef idx="0">
+        <a:scrgbClr r="0" g="0" b="0"/>
+      </a:fillRef>
+      <a:effectRef idx="0">
+        <a:scrgbClr r="0" g="0" b="0"/>
+      </a:effectRef>
+      <a:fontRef idx="minor"/>
+    </dgm:style>
+  </dgm:styleLbl>
+</dgm:styleDef>
+</file>
+
 <file path=ppt/handoutMasters/handoutMaster1.xml><?xml version="1.0" encoding="utf-8"?>
 <p:handoutMaster xmlns:a="http://schemas.openxmlformats.org/drawingml/2006/main" xmlns:r="http://schemas.openxmlformats.org/officeDocument/2006/relationships" xmlns:p="http://schemas.openxmlformats.org/presentationml/2006/main">
   <p:cSld>
@@ -259,7 +3610,7 @@
             <a:fld id="{EC9388A7-5429-7442-BD81-798B3F4B5BE0}" type="datetime1">
               <a:rPr lang="it-IT"/>
               <a:pPr/>
-              <a:t>30/04/26</a:t>
+              <a:t>02/05/26</a:t>
             </a:fld>
             <a:endParaRPr lang="it-IT"/>
           </a:p>
@@ -510,14 +3861,14 @@
           </a:ln>
           <a:extLst>
             <a:ext uri="{909E8E84-426E-40dd-AFC4-6F175D3DCCD1}">
-              <a14:hiddenFill xmlns:a14="http://schemas.microsoft.com/office/drawing/2010/main" xmlns="">
+              <a14:hiddenFill xmlns="" xmlns:a14="http://schemas.microsoft.com/office/drawing/2010/main">
                 <a:solidFill>
                   <a:srgbClr val="FFFFFF"/>
                 </a:solidFill>
               </a14:hiddenFill>
             </a:ext>
             <a:ext uri="{FAA26D3D-D897-4be2-8F04-BA451C77F1D7}">
-              <ma14:placeholderFlag xmlns:ma14="http://schemas.microsoft.com/office/mac/drawingml/2011/main" xmlns="" val="1"/>
+              <ma14:placeholderFlag xmlns="" xmlns:ma14="http://schemas.microsoft.com/office/mac/drawingml/2011/main" val="1"/>
             </a:ext>
           </a:extLst>
         </p:spPr>
@@ -5141,25 +8492,6 @@
       </p:grpSpPr>
       <p:sp>
         <p:nvSpPr>
-          <p:cNvPr id="2" name="Segnaposto testo 1"/>
-          <p:cNvSpPr>
-            <a:spLocks noGrp="1"/>
-          </p:cNvSpPr>
-          <p:nvPr>
-            <p:ph type="body" sz="quarter" idx="13"/>
-          </p:nvPr>
-        </p:nvSpPr>
-        <p:spPr/>
-        <p:txBody>
-          <a:bodyPr/>
-          <a:lstStyle/>
-          <a:p>
-            <a:endParaRPr lang="it-IT" dirty="0"/>
-          </a:p>
-        </p:txBody>
-      </p:sp>
-      <p:sp>
-        <p:nvSpPr>
           <p:cNvPr id="3" name="Segnaposto testo 2"/>
           <p:cNvSpPr>
             <a:spLocks noGrp="1"/>
@@ -5173,57 +8505,41 @@
           <a:bodyPr/>
           <a:lstStyle/>
           <a:p>
-            <a:endParaRPr lang="it-IT"/>
+            <a:r>
+              <a:rPr lang="it-IT" dirty="0"/>
+              <a:t>Indice</a:t>
+            </a:r>
           </a:p>
         </p:txBody>
       </p:sp>
-      <p:sp>
-        <p:nvSpPr>
-          <p:cNvPr id="4" name="Rettangolo 3"/>
-          <p:cNvSpPr/>
-          <p:nvPr/>
-        </p:nvSpPr>
-        <p:spPr>
-          <a:xfrm>
-            <a:off x="4409982" y="1778470"/>
-            <a:ext cx="2862318" cy="3132348"/>
-          </a:xfrm>
-          <a:prstGeom prst="rect">
-            <a:avLst/>
-          </a:prstGeom>
-          <a:solidFill>
-            <a:schemeClr val="bg2">
-              <a:lumMod val="85000"/>
-            </a:schemeClr>
-          </a:solidFill>
-          <a:ln>
-            <a:noFill/>
-          </a:ln>
-          <a:effectLst/>
-        </p:spPr>
-        <p:style>
-          <a:lnRef idx="1">
-            <a:schemeClr val="accent1"/>
-          </a:lnRef>
-          <a:fillRef idx="3">
-            <a:schemeClr val="accent1"/>
-          </a:fillRef>
-          <a:effectRef idx="2">
-            <a:schemeClr val="accent1"/>
-          </a:effectRef>
-          <a:fontRef idx="minor">
-            <a:schemeClr val="lt1"/>
-          </a:fontRef>
-        </p:style>
-        <p:txBody>
-          <a:bodyPr rtlCol="0" anchor="ctr"/>
-          <a:lstStyle/>
-          <a:p>
-            <a:pPr algn="ctr"/>
-            <a:endParaRPr lang="it-IT"/>
-          </a:p>
-        </p:txBody>
-      </p:sp>
+      <p:graphicFrame>
+        <p:nvGraphicFramePr>
+          <p:cNvPr id="6" name="Diagram 5">
+            <a:extLst>
+              <a:ext uri="{FF2B5EF4-FFF2-40B4-BE49-F238E27FC236}">
+                <a16:creationId xmlns:a16="http://schemas.microsoft.com/office/drawing/2014/main" id="{626A6A45-214A-DAA6-7A8E-39143711F45C}"/>
+              </a:ext>
+            </a:extLst>
+          </p:cNvPr>
+          <p:cNvGraphicFramePr/>
+          <p:nvPr>
+            <p:extLst>
+              <p:ext uri="{D42A27DB-BD31-4B8C-83A1-F6EECF244321}">
+                <p14:modId xmlns:p14="http://schemas.microsoft.com/office/powerpoint/2010/main" val="834965464"/>
+              </p:ext>
+            </p:extLst>
+          </p:nvPr>
+        </p:nvGraphicFramePr>
+        <p:xfrm>
+          <a:off x="467544" y="1347614"/>
+          <a:ext cx="7944544" cy="3600400"/>
+        </p:xfrm>
+        <a:graphic>
+          <a:graphicData uri="http://schemas.openxmlformats.org/drawingml/2006/diagram">
+            <dgm:relIds xmlns:dgm="http://schemas.openxmlformats.org/drawingml/2006/diagram" xmlns:r="http://schemas.openxmlformats.org/officeDocument/2006/relationships" r:dm="rId2" r:lo="rId3" r:qs="rId4" r:cs="rId5"/>
+          </a:graphicData>
+        </a:graphic>
+      </p:graphicFrame>
     </p:spTree>
     <p:extLst>
       <p:ext uri="{BB962C8B-B14F-4D97-AF65-F5344CB8AC3E}">
@@ -5242,7 +8558,13 @@
   <p:cSld>
     <p:spTree>
       <p:nvGrpSpPr>
-        <p:cNvPr id="1" name=""/>
+        <p:cNvPr id="1" name="">
+          <a:extLst>
+            <a:ext uri="{FF2B5EF4-FFF2-40B4-BE49-F238E27FC236}">
+              <a16:creationId xmlns:a16="http://schemas.microsoft.com/office/drawing/2014/main" id="{1C4751A3-85C7-AEF8-0C65-5D06CFE4AACF}"/>
+            </a:ext>
+          </a:extLst>
+        </p:cNvPr>
         <p:cNvGrpSpPr/>
         <p:nvPr/>
       </p:nvGrpSpPr>
@@ -5256,12 +8578,61 @@
       </p:grpSpPr>
       <p:sp>
         <p:nvSpPr>
-          <p:cNvPr id="2" name="Segnaposto testo 1"/>
+          <p:cNvPr id="2" name="Segnaposto testo 1">
+            <a:extLst>
+              <a:ext uri="{FF2B5EF4-FFF2-40B4-BE49-F238E27FC236}">
+                <a16:creationId xmlns:a16="http://schemas.microsoft.com/office/drawing/2014/main" id="{4AA81E5A-4D54-E567-FE93-8EA7A744F3C4}"/>
+              </a:ext>
+            </a:extLst>
+          </p:cNvPr>
           <p:cNvSpPr>
             <a:spLocks noGrp="1"/>
           </p:cNvSpPr>
           <p:nvPr>
-            <p:ph type="body" sz="quarter" idx="15"/>
+            <p:ph type="body" sz="quarter" idx="13"/>
+          </p:nvPr>
+        </p:nvSpPr>
+        <p:spPr>
+          <a:xfrm>
+            <a:off x="323528" y="1736229"/>
+            <a:ext cx="7848872" cy="3186354"/>
+          </a:xfrm>
+        </p:spPr>
+        <p:txBody>
+          <a:bodyPr/>
+          <a:lstStyle/>
+          <a:p>
+            <a:r>
+              <a:rPr lang="en-GB" dirty="0" err="1"/>
+              <a:t>Frequentiamo</a:t>
+            </a:r>
+            <a:r>
+              <a:rPr lang="en-GB" dirty="0"/>
+              <a:t> la SUPSI (6°semestre)</a:t>
+            </a:r>
+          </a:p>
+          <a:p>
+            <a:endParaRPr lang="en-GB" dirty="0"/>
+          </a:p>
+          <a:p>
+            <a:endParaRPr lang="en-GB" dirty="0"/>
+          </a:p>
+        </p:txBody>
+      </p:sp>
+      <p:sp>
+        <p:nvSpPr>
+          <p:cNvPr id="3" name="Segnaposto testo 2">
+            <a:extLst>
+              <a:ext uri="{FF2B5EF4-FFF2-40B4-BE49-F238E27FC236}">
+                <a16:creationId xmlns:a16="http://schemas.microsoft.com/office/drawing/2014/main" id="{CAD3A587-A57C-9036-A77B-25DC8ECF47ED}"/>
+              </a:ext>
+            </a:extLst>
+          </p:cNvPr>
+          <p:cNvSpPr>
+            <a:spLocks noGrp="1"/>
+          </p:cNvSpPr>
+          <p:nvPr>
+            <p:ph type="body" sz="quarter" idx="14"/>
           </p:nvPr>
         </p:nvSpPr>
         <p:spPr/>
@@ -5269,61 +8640,29 @@
           <a:bodyPr/>
           <a:lstStyle/>
           <a:p>
-            <a:endParaRPr lang="it-IT"/>
+            <a:r>
+              <a:rPr lang="en-GB" dirty="0" err="1"/>
+              <a:t>Contesto</a:t>
+            </a:r>
+            <a:r>
+              <a:rPr lang="en-GB" dirty="0"/>
+              <a:t> e </a:t>
+            </a:r>
+            <a:r>
+              <a:rPr lang="en-GB" dirty="0" err="1"/>
+              <a:t>Motivazione</a:t>
+            </a:r>
+            <a:endParaRPr lang="en-GB" dirty="0"/>
           </a:p>
-        </p:txBody>
-      </p:sp>
-      <p:sp>
-        <p:nvSpPr>
-          <p:cNvPr id="3" name="Rettangolo 2"/>
-          <p:cNvSpPr/>
-          <p:nvPr/>
-        </p:nvSpPr>
-        <p:spPr>
-          <a:xfrm>
-            <a:off x="4409982" y="951570"/>
-            <a:ext cx="2862318" cy="3959248"/>
-          </a:xfrm>
-          <a:prstGeom prst="rect">
-            <a:avLst/>
-          </a:prstGeom>
-          <a:solidFill>
-            <a:schemeClr val="bg2">
-              <a:lumMod val="85000"/>
-            </a:schemeClr>
-          </a:solidFill>
-          <a:ln>
-            <a:noFill/>
-          </a:ln>
-          <a:effectLst/>
-        </p:spPr>
-        <p:style>
-          <a:lnRef idx="1">
-            <a:schemeClr val="accent1"/>
-          </a:lnRef>
-          <a:fillRef idx="3">
-            <a:schemeClr val="accent1"/>
-          </a:fillRef>
-          <a:effectRef idx="2">
-            <a:schemeClr val="accent1"/>
-          </a:effectRef>
-          <a:fontRef idx="minor">
-            <a:schemeClr val="lt1"/>
-          </a:fontRef>
-        </p:style>
-        <p:txBody>
-          <a:bodyPr rtlCol="0" anchor="ctr"/>
-          <a:lstStyle/>
           <a:p>
-            <a:pPr algn="ctr"/>
-            <a:endParaRPr lang="it-IT"/>
+            <a:endParaRPr lang="it-IT" dirty="0"/>
           </a:p>
         </p:txBody>
       </p:sp>
     </p:spTree>
     <p:extLst>
       <p:ext uri="{BB962C8B-B14F-4D97-AF65-F5344CB8AC3E}">
-        <p14:creationId xmlns:p14="http://schemas.microsoft.com/office/powerpoint/2010/main" val="1319600840"/>
+        <p14:creationId xmlns:p14="http://schemas.microsoft.com/office/powerpoint/2010/main" val="3826340877"/>
       </p:ext>
     </p:extLst>
   </p:cSld>
@@ -5338,7 +8677,13 @@
   <p:cSld>
     <p:spTree>
       <p:nvGrpSpPr>
-        <p:cNvPr id="1" name=""/>
+        <p:cNvPr id="1" name="">
+          <a:extLst>
+            <a:ext uri="{FF2B5EF4-FFF2-40B4-BE49-F238E27FC236}">
+              <a16:creationId xmlns:a16="http://schemas.microsoft.com/office/drawing/2014/main" id="{6C4316F3-728A-5F74-60E3-7D420B17FFA8}"/>
+            </a:ext>
+          </a:extLst>
+        </p:cNvPr>
         <p:cNvGrpSpPr/>
         <p:nvPr/>
       </p:nvGrpSpPr>
@@ -5352,7 +8697,13 @@
       </p:grpSpPr>
       <p:sp>
         <p:nvSpPr>
-          <p:cNvPr id="2" name="Segnaposto testo 1"/>
+          <p:cNvPr id="2" name="Segnaposto testo 1">
+            <a:extLst>
+              <a:ext uri="{FF2B5EF4-FFF2-40B4-BE49-F238E27FC236}">
+                <a16:creationId xmlns:a16="http://schemas.microsoft.com/office/drawing/2014/main" id="{021C7A46-BDD0-73BE-E60B-CADEC40A8209}"/>
+              </a:ext>
+            </a:extLst>
+          </p:cNvPr>
           <p:cNvSpPr>
             <a:spLocks noGrp="1"/>
           </p:cNvSpPr>
@@ -5360,7 +8711,12 @@
             <p:ph type="body" sz="quarter" idx="13"/>
           </p:nvPr>
         </p:nvSpPr>
-        <p:spPr/>
+        <p:spPr>
+          <a:xfrm>
+            <a:off x="323528" y="1736229"/>
+            <a:ext cx="7848872" cy="3186354"/>
+          </a:xfrm>
+        </p:spPr>
         <p:txBody>
           <a:bodyPr/>
           <a:lstStyle/>
@@ -5371,55 +8727,514 @@
       </p:sp>
       <p:sp>
         <p:nvSpPr>
-          <p:cNvPr id="5" name="Rettangolo 4"/>
-          <p:cNvSpPr/>
-          <p:nvPr/>
+          <p:cNvPr id="3" name="Segnaposto testo 2">
+            <a:extLst>
+              <a:ext uri="{FF2B5EF4-FFF2-40B4-BE49-F238E27FC236}">
+                <a16:creationId xmlns:a16="http://schemas.microsoft.com/office/drawing/2014/main" id="{6E3704BD-3760-CAE4-9354-78B504C4EA23}"/>
+              </a:ext>
+            </a:extLst>
+          </p:cNvPr>
+          <p:cNvSpPr>
+            <a:spLocks noGrp="1"/>
+          </p:cNvSpPr>
+          <p:nvPr>
+            <p:ph type="body" sz="quarter" idx="14"/>
+          </p:nvPr>
         </p:nvSpPr>
-        <p:spPr>
-          <a:xfrm>
-            <a:off x="3437874" y="951570"/>
-            <a:ext cx="3834426" cy="3959248"/>
-          </a:xfrm>
-          <a:prstGeom prst="rect">
-            <a:avLst/>
-          </a:prstGeom>
-          <a:solidFill>
-            <a:schemeClr val="bg2">
-              <a:lumMod val="85000"/>
-            </a:schemeClr>
-          </a:solidFill>
-          <a:ln>
-            <a:noFill/>
-          </a:ln>
-          <a:effectLst/>
-        </p:spPr>
-        <p:style>
-          <a:lnRef idx="1">
-            <a:schemeClr val="accent1"/>
-          </a:lnRef>
-          <a:fillRef idx="3">
-            <a:schemeClr val="accent1"/>
-          </a:fillRef>
-          <a:effectRef idx="2">
-            <a:schemeClr val="accent1"/>
-          </a:effectRef>
-          <a:fontRef idx="minor">
-            <a:schemeClr val="lt1"/>
-          </a:fontRef>
-        </p:style>
+        <p:spPr/>
         <p:txBody>
-          <a:bodyPr rtlCol="0" anchor="ctr"/>
+          <a:bodyPr/>
           <a:lstStyle/>
           <a:p>
-            <a:pPr algn="ctr"/>
-            <a:endParaRPr lang="it-IT"/>
+            <a:r>
+              <a:rPr lang="en-GB" dirty="0" err="1"/>
+              <a:t>Obbiettivo</a:t>
+            </a:r>
+            <a:endParaRPr lang="en-GB" dirty="0"/>
+          </a:p>
+          <a:p>
+            <a:endParaRPr lang="it-IT" dirty="0"/>
           </a:p>
         </p:txBody>
       </p:sp>
     </p:spTree>
     <p:extLst>
       <p:ext uri="{BB962C8B-B14F-4D97-AF65-F5344CB8AC3E}">
-        <p14:creationId xmlns:p14="http://schemas.microsoft.com/office/powerpoint/2010/main" val="2104085732"/>
+        <p14:creationId xmlns:p14="http://schemas.microsoft.com/office/powerpoint/2010/main" val="2444796194"/>
+      </p:ext>
+    </p:extLst>
+  </p:cSld>
+  <p:clrMapOvr>
+    <a:masterClrMapping/>
+  </p:clrMapOvr>
+</p:sld>
+</file>
+
+<file path=ppt/slides/slide5.xml><?xml version="1.0" encoding="utf-8"?>
+<p:sld xmlns:a="http://schemas.openxmlformats.org/drawingml/2006/main" xmlns:r="http://schemas.openxmlformats.org/officeDocument/2006/relationships" xmlns:p="http://schemas.openxmlformats.org/presentationml/2006/main">
+  <p:cSld>
+    <p:spTree>
+      <p:nvGrpSpPr>
+        <p:cNvPr id="1" name="">
+          <a:extLst>
+            <a:ext uri="{FF2B5EF4-FFF2-40B4-BE49-F238E27FC236}">
+              <a16:creationId xmlns:a16="http://schemas.microsoft.com/office/drawing/2014/main" id="{3A4CED3D-0CE9-A511-026D-86581C9BB213}"/>
+            </a:ext>
+          </a:extLst>
+        </p:cNvPr>
+        <p:cNvGrpSpPr/>
+        <p:nvPr/>
+      </p:nvGrpSpPr>
+      <p:grpSpPr>
+        <a:xfrm>
+          <a:off x="0" y="0"/>
+          <a:ext cx="0" cy="0"/>
+          <a:chOff x="0" y="0"/>
+          <a:chExt cx="0" cy="0"/>
+        </a:xfrm>
+      </p:grpSpPr>
+      <p:sp>
+        <p:nvSpPr>
+          <p:cNvPr id="2" name="Segnaposto testo 1">
+            <a:extLst>
+              <a:ext uri="{FF2B5EF4-FFF2-40B4-BE49-F238E27FC236}">
+                <a16:creationId xmlns:a16="http://schemas.microsoft.com/office/drawing/2014/main" id="{F5FC6347-DD2A-A3E0-C9C7-3135D7D96889}"/>
+              </a:ext>
+            </a:extLst>
+          </p:cNvPr>
+          <p:cNvSpPr>
+            <a:spLocks noGrp="1"/>
+          </p:cNvSpPr>
+          <p:nvPr>
+            <p:ph type="body" sz="quarter" idx="13"/>
+          </p:nvPr>
+        </p:nvSpPr>
+        <p:spPr>
+          <a:xfrm>
+            <a:off x="323528" y="1736229"/>
+            <a:ext cx="7848872" cy="3186354"/>
+          </a:xfrm>
+        </p:spPr>
+        <p:txBody>
+          <a:bodyPr/>
+          <a:lstStyle/>
+          <a:p>
+            <a:endParaRPr lang="it-IT" dirty="0"/>
+          </a:p>
+        </p:txBody>
+      </p:sp>
+      <p:sp>
+        <p:nvSpPr>
+          <p:cNvPr id="3" name="Segnaposto testo 2">
+            <a:extLst>
+              <a:ext uri="{FF2B5EF4-FFF2-40B4-BE49-F238E27FC236}">
+                <a16:creationId xmlns:a16="http://schemas.microsoft.com/office/drawing/2014/main" id="{A29F684B-3555-A7F5-2D78-625B01C47778}"/>
+              </a:ext>
+            </a:extLst>
+          </p:cNvPr>
+          <p:cNvSpPr>
+            <a:spLocks noGrp="1"/>
+          </p:cNvSpPr>
+          <p:nvPr>
+            <p:ph type="body" sz="quarter" idx="14"/>
+          </p:nvPr>
+        </p:nvSpPr>
+        <p:spPr/>
+        <p:txBody>
+          <a:bodyPr/>
+          <a:lstStyle/>
+          <a:p>
+            <a:r>
+              <a:rPr lang="en-GB" dirty="0" err="1"/>
+              <a:t>Problemi</a:t>
+            </a:r>
+            <a:endParaRPr lang="en-GB" dirty="0"/>
+          </a:p>
+        </p:txBody>
+      </p:sp>
+    </p:spTree>
+    <p:extLst>
+      <p:ext uri="{BB962C8B-B14F-4D97-AF65-F5344CB8AC3E}">
+        <p14:creationId xmlns:p14="http://schemas.microsoft.com/office/powerpoint/2010/main" val="1672352230"/>
+      </p:ext>
+    </p:extLst>
+  </p:cSld>
+  <p:clrMapOvr>
+    <a:masterClrMapping/>
+  </p:clrMapOvr>
+</p:sld>
+</file>
+
+<file path=ppt/slides/slide6.xml><?xml version="1.0" encoding="utf-8"?>
+<p:sld xmlns:a="http://schemas.openxmlformats.org/drawingml/2006/main" xmlns:r="http://schemas.openxmlformats.org/officeDocument/2006/relationships" xmlns:p="http://schemas.openxmlformats.org/presentationml/2006/main">
+  <p:cSld>
+    <p:spTree>
+      <p:nvGrpSpPr>
+        <p:cNvPr id="1" name="">
+          <a:extLst>
+            <a:ext uri="{FF2B5EF4-FFF2-40B4-BE49-F238E27FC236}">
+              <a16:creationId xmlns:a16="http://schemas.microsoft.com/office/drawing/2014/main" id="{95B84598-429A-33A0-2617-F5E18D8C2BEA}"/>
+            </a:ext>
+          </a:extLst>
+        </p:cNvPr>
+        <p:cNvGrpSpPr/>
+        <p:nvPr/>
+      </p:nvGrpSpPr>
+      <p:grpSpPr>
+        <a:xfrm>
+          <a:off x="0" y="0"/>
+          <a:ext cx="0" cy="0"/>
+          <a:chOff x="0" y="0"/>
+          <a:chExt cx="0" cy="0"/>
+        </a:xfrm>
+      </p:grpSpPr>
+      <p:sp>
+        <p:nvSpPr>
+          <p:cNvPr id="2" name="Segnaposto testo 1">
+            <a:extLst>
+              <a:ext uri="{FF2B5EF4-FFF2-40B4-BE49-F238E27FC236}">
+                <a16:creationId xmlns:a16="http://schemas.microsoft.com/office/drawing/2014/main" id="{5BA4A93F-86EE-3AE6-E2BC-75457DB3C715}"/>
+              </a:ext>
+            </a:extLst>
+          </p:cNvPr>
+          <p:cNvSpPr>
+            <a:spLocks noGrp="1"/>
+          </p:cNvSpPr>
+          <p:nvPr>
+            <p:ph type="body" sz="quarter" idx="13"/>
+          </p:nvPr>
+        </p:nvSpPr>
+        <p:spPr>
+          <a:xfrm>
+            <a:off x="323528" y="1736229"/>
+            <a:ext cx="7848872" cy="3186354"/>
+          </a:xfrm>
+        </p:spPr>
+        <p:txBody>
+          <a:bodyPr/>
+          <a:lstStyle/>
+          <a:p>
+            <a:endParaRPr lang="it-IT" dirty="0"/>
+          </a:p>
+        </p:txBody>
+      </p:sp>
+      <p:sp>
+        <p:nvSpPr>
+          <p:cNvPr id="3" name="Segnaposto testo 2">
+            <a:extLst>
+              <a:ext uri="{FF2B5EF4-FFF2-40B4-BE49-F238E27FC236}">
+                <a16:creationId xmlns:a16="http://schemas.microsoft.com/office/drawing/2014/main" id="{48DC585A-70A0-C7A4-585A-CAFE329B1217}"/>
+              </a:ext>
+            </a:extLst>
+          </p:cNvPr>
+          <p:cNvSpPr>
+            <a:spLocks noGrp="1"/>
+          </p:cNvSpPr>
+          <p:nvPr>
+            <p:ph type="body" sz="quarter" idx="14"/>
+          </p:nvPr>
+        </p:nvSpPr>
+        <p:spPr/>
+        <p:txBody>
+          <a:bodyPr/>
+          <a:lstStyle/>
+          <a:p>
+            <a:r>
+              <a:rPr lang="en-GB" dirty="0"/>
+              <a:t>Stato dell’arte</a:t>
+            </a:r>
+          </a:p>
+        </p:txBody>
+      </p:sp>
+    </p:spTree>
+    <p:extLst>
+      <p:ext uri="{BB962C8B-B14F-4D97-AF65-F5344CB8AC3E}">
+        <p14:creationId xmlns:p14="http://schemas.microsoft.com/office/powerpoint/2010/main" val="2899734786"/>
+      </p:ext>
+    </p:extLst>
+  </p:cSld>
+  <p:clrMapOvr>
+    <a:masterClrMapping/>
+  </p:clrMapOvr>
+</p:sld>
+</file>
+
+<file path=ppt/slides/slide7.xml><?xml version="1.0" encoding="utf-8"?>
+<p:sld xmlns:a="http://schemas.openxmlformats.org/drawingml/2006/main" xmlns:r="http://schemas.openxmlformats.org/officeDocument/2006/relationships" xmlns:p="http://schemas.openxmlformats.org/presentationml/2006/main">
+  <p:cSld>
+    <p:spTree>
+      <p:nvGrpSpPr>
+        <p:cNvPr id="1" name="">
+          <a:extLst>
+            <a:ext uri="{FF2B5EF4-FFF2-40B4-BE49-F238E27FC236}">
+              <a16:creationId xmlns:a16="http://schemas.microsoft.com/office/drawing/2014/main" id="{D1D57E90-216C-82CA-793D-C1F4C92045B1}"/>
+            </a:ext>
+          </a:extLst>
+        </p:cNvPr>
+        <p:cNvGrpSpPr/>
+        <p:nvPr/>
+      </p:nvGrpSpPr>
+      <p:grpSpPr>
+        <a:xfrm>
+          <a:off x="0" y="0"/>
+          <a:ext cx="0" cy="0"/>
+          <a:chOff x="0" y="0"/>
+          <a:chExt cx="0" cy="0"/>
+        </a:xfrm>
+      </p:grpSpPr>
+      <p:sp>
+        <p:nvSpPr>
+          <p:cNvPr id="2" name="Segnaposto testo 1">
+            <a:extLst>
+              <a:ext uri="{FF2B5EF4-FFF2-40B4-BE49-F238E27FC236}">
+                <a16:creationId xmlns:a16="http://schemas.microsoft.com/office/drawing/2014/main" id="{A12C4C9B-F6C2-DCC4-00F0-30F730F8E5D5}"/>
+              </a:ext>
+            </a:extLst>
+          </p:cNvPr>
+          <p:cNvSpPr>
+            <a:spLocks noGrp="1"/>
+          </p:cNvSpPr>
+          <p:nvPr>
+            <p:ph type="body" sz="quarter" idx="13"/>
+          </p:nvPr>
+        </p:nvSpPr>
+        <p:spPr>
+          <a:xfrm>
+            <a:off x="323528" y="1736229"/>
+            <a:ext cx="7848872" cy="3186354"/>
+          </a:xfrm>
+        </p:spPr>
+        <p:txBody>
+          <a:bodyPr/>
+          <a:lstStyle/>
+          <a:p>
+            <a:endParaRPr lang="it-IT" dirty="0"/>
+          </a:p>
+        </p:txBody>
+      </p:sp>
+      <p:sp>
+        <p:nvSpPr>
+          <p:cNvPr id="3" name="Segnaposto testo 2">
+            <a:extLst>
+              <a:ext uri="{FF2B5EF4-FFF2-40B4-BE49-F238E27FC236}">
+                <a16:creationId xmlns:a16="http://schemas.microsoft.com/office/drawing/2014/main" id="{EAE31DA4-C79C-BF3E-BAE9-97235DF095BC}"/>
+              </a:ext>
+            </a:extLst>
+          </p:cNvPr>
+          <p:cNvSpPr>
+            <a:spLocks noGrp="1"/>
+          </p:cNvSpPr>
+          <p:nvPr>
+            <p:ph type="body" sz="quarter" idx="14"/>
+          </p:nvPr>
+        </p:nvSpPr>
+        <p:spPr/>
+        <p:txBody>
+          <a:bodyPr/>
+          <a:lstStyle/>
+          <a:p>
+            <a:r>
+              <a:rPr lang="en-GB" dirty="0" err="1"/>
+              <a:t>Approccio</a:t>
+            </a:r>
+            <a:endParaRPr lang="en-GB" dirty="0"/>
+          </a:p>
+        </p:txBody>
+      </p:sp>
+    </p:spTree>
+    <p:extLst>
+      <p:ext uri="{BB962C8B-B14F-4D97-AF65-F5344CB8AC3E}">
+        <p14:creationId xmlns:p14="http://schemas.microsoft.com/office/powerpoint/2010/main" val="732724168"/>
+      </p:ext>
+    </p:extLst>
+  </p:cSld>
+  <p:clrMapOvr>
+    <a:masterClrMapping/>
+  </p:clrMapOvr>
+</p:sld>
+</file>
+
+<file path=ppt/slides/slide8.xml><?xml version="1.0" encoding="utf-8"?>
+<p:sld xmlns:a="http://schemas.openxmlformats.org/drawingml/2006/main" xmlns:r="http://schemas.openxmlformats.org/officeDocument/2006/relationships" xmlns:p="http://schemas.openxmlformats.org/presentationml/2006/main">
+  <p:cSld>
+    <p:spTree>
+      <p:nvGrpSpPr>
+        <p:cNvPr id="1" name="">
+          <a:extLst>
+            <a:ext uri="{FF2B5EF4-FFF2-40B4-BE49-F238E27FC236}">
+              <a16:creationId xmlns:a16="http://schemas.microsoft.com/office/drawing/2014/main" id="{4A821E4B-80BB-E6C6-CD1A-EC0AEEA8E8FE}"/>
+            </a:ext>
+          </a:extLst>
+        </p:cNvPr>
+        <p:cNvGrpSpPr/>
+        <p:nvPr/>
+      </p:nvGrpSpPr>
+      <p:grpSpPr>
+        <a:xfrm>
+          <a:off x="0" y="0"/>
+          <a:ext cx="0" cy="0"/>
+          <a:chOff x="0" y="0"/>
+          <a:chExt cx="0" cy="0"/>
+        </a:xfrm>
+      </p:grpSpPr>
+      <p:sp>
+        <p:nvSpPr>
+          <p:cNvPr id="2" name="Segnaposto testo 1">
+            <a:extLst>
+              <a:ext uri="{FF2B5EF4-FFF2-40B4-BE49-F238E27FC236}">
+                <a16:creationId xmlns:a16="http://schemas.microsoft.com/office/drawing/2014/main" id="{02BBFD56-3D6F-FA05-397D-18E11E8BEB72}"/>
+              </a:ext>
+            </a:extLst>
+          </p:cNvPr>
+          <p:cNvSpPr>
+            <a:spLocks noGrp="1"/>
+          </p:cNvSpPr>
+          <p:nvPr>
+            <p:ph type="body" sz="quarter" idx="13"/>
+          </p:nvPr>
+        </p:nvSpPr>
+        <p:spPr>
+          <a:xfrm>
+            <a:off x="323528" y="1736229"/>
+            <a:ext cx="7848872" cy="3186354"/>
+          </a:xfrm>
+        </p:spPr>
+        <p:txBody>
+          <a:bodyPr/>
+          <a:lstStyle/>
+          <a:p>
+            <a:endParaRPr lang="it-IT" dirty="0"/>
+          </a:p>
+        </p:txBody>
+      </p:sp>
+      <p:sp>
+        <p:nvSpPr>
+          <p:cNvPr id="3" name="Segnaposto testo 2">
+            <a:extLst>
+              <a:ext uri="{FF2B5EF4-FFF2-40B4-BE49-F238E27FC236}">
+                <a16:creationId xmlns:a16="http://schemas.microsoft.com/office/drawing/2014/main" id="{48E799BA-DC44-3C2C-83CB-00887C551690}"/>
+              </a:ext>
+            </a:extLst>
+          </p:cNvPr>
+          <p:cNvSpPr>
+            <a:spLocks noGrp="1"/>
+          </p:cNvSpPr>
+          <p:nvPr>
+            <p:ph type="body" sz="quarter" idx="14"/>
+          </p:nvPr>
+        </p:nvSpPr>
+        <p:spPr/>
+        <p:txBody>
+          <a:bodyPr/>
+          <a:lstStyle/>
+          <a:p>
+            <a:r>
+              <a:rPr lang="en-GB" dirty="0" err="1"/>
+              <a:t>Risultato</a:t>
+            </a:r>
+            <a:endParaRPr lang="en-GB" dirty="0"/>
+          </a:p>
+        </p:txBody>
+      </p:sp>
+    </p:spTree>
+    <p:extLst>
+      <p:ext uri="{BB962C8B-B14F-4D97-AF65-F5344CB8AC3E}">
+        <p14:creationId xmlns:p14="http://schemas.microsoft.com/office/powerpoint/2010/main" val="1507575960"/>
+      </p:ext>
+    </p:extLst>
+  </p:cSld>
+  <p:clrMapOvr>
+    <a:masterClrMapping/>
+  </p:clrMapOvr>
+</p:sld>
+</file>
+
+<file path=ppt/slides/slide9.xml><?xml version="1.0" encoding="utf-8"?>
+<p:sld xmlns:a="http://schemas.openxmlformats.org/drawingml/2006/main" xmlns:r="http://schemas.openxmlformats.org/officeDocument/2006/relationships" xmlns:p="http://schemas.openxmlformats.org/presentationml/2006/main">
+  <p:cSld>
+    <p:spTree>
+      <p:nvGrpSpPr>
+        <p:cNvPr id="1" name="">
+          <a:extLst>
+            <a:ext uri="{FF2B5EF4-FFF2-40B4-BE49-F238E27FC236}">
+              <a16:creationId xmlns:a16="http://schemas.microsoft.com/office/drawing/2014/main" id="{491DA62B-E4B2-AF5A-51DB-41820BF704F6}"/>
+            </a:ext>
+          </a:extLst>
+        </p:cNvPr>
+        <p:cNvGrpSpPr/>
+        <p:nvPr/>
+      </p:nvGrpSpPr>
+      <p:grpSpPr>
+        <a:xfrm>
+          <a:off x="0" y="0"/>
+          <a:ext cx="0" cy="0"/>
+          <a:chOff x="0" y="0"/>
+          <a:chExt cx="0" cy="0"/>
+        </a:xfrm>
+      </p:grpSpPr>
+      <p:sp>
+        <p:nvSpPr>
+          <p:cNvPr id="2" name="Segnaposto testo 1">
+            <a:extLst>
+              <a:ext uri="{FF2B5EF4-FFF2-40B4-BE49-F238E27FC236}">
+                <a16:creationId xmlns:a16="http://schemas.microsoft.com/office/drawing/2014/main" id="{18450BB1-87B0-05FC-D80E-20A699CF539D}"/>
+              </a:ext>
+            </a:extLst>
+          </p:cNvPr>
+          <p:cNvSpPr>
+            <a:spLocks noGrp="1"/>
+          </p:cNvSpPr>
+          <p:nvPr>
+            <p:ph type="body" sz="quarter" idx="13"/>
+          </p:nvPr>
+        </p:nvSpPr>
+        <p:spPr>
+          <a:xfrm>
+            <a:off x="323528" y="1736229"/>
+            <a:ext cx="7848872" cy="3186354"/>
+          </a:xfrm>
+        </p:spPr>
+        <p:txBody>
+          <a:bodyPr/>
+          <a:lstStyle/>
+          <a:p>
+            <a:endParaRPr lang="it-IT" dirty="0"/>
+          </a:p>
+        </p:txBody>
+      </p:sp>
+      <p:sp>
+        <p:nvSpPr>
+          <p:cNvPr id="3" name="Segnaposto testo 2">
+            <a:extLst>
+              <a:ext uri="{FF2B5EF4-FFF2-40B4-BE49-F238E27FC236}">
+                <a16:creationId xmlns:a16="http://schemas.microsoft.com/office/drawing/2014/main" id="{94C2FD86-6877-674E-E51E-EBF78EF6EE83}"/>
+              </a:ext>
+            </a:extLst>
+          </p:cNvPr>
+          <p:cNvSpPr>
+            <a:spLocks noGrp="1"/>
+          </p:cNvSpPr>
+          <p:nvPr>
+            <p:ph type="body" sz="quarter" idx="14"/>
+          </p:nvPr>
+        </p:nvSpPr>
+        <p:spPr/>
+        <p:txBody>
+          <a:bodyPr/>
+          <a:lstStyle/>
+          <a:p>
+            <a:r>
+              <a:rPr lang="en-GB" dirty="0" err="1"/>
+              <a:t>Conclusioni</a:t>
+            </a:r>
+            <a:endParaRPr lang="en-GB" dirty="0"/>
+          </a:p>
+        </p:txBody>
+      </p:sp>
+    </p:spTree>
+    <p:extLst>
+      <p:ext uri="{BB962C8B-B14F-4D97-AF65-F5344CB8AC3E}">
+        <p14:creationId xmlns:p14="http://schemas.microsoft.com/office/powerpoint/2010/main" val="2375732288"/>
       </p:ext>
     </p:extLst>
   </p:cSld>

</xml_diff>